<commit_message>
Add validation tests and methods/validation slides
- Created validate_findings.py with 4 validation tests (global FDR,
  permutation null, hold-out split, cross-dataset)
- Permutation results: 0/100 shuffles beat top 2 findings, 0/20
  simulations produced any significant result
- Hold-out: all 3 effect directions consistent, 2/3 p<0.05 in validation
- Added Methods slide (data split, classifier pipeline)
- Added Validation slide (permutation + hold-out results)

Co-Authored-By: Claude Opus 4.6 <noreply@anthropic.com>
</commit_message>
<xml_diff>
--- a/AutoBiomarker_Evolved26.pptx
+++ b/AutoBiomarker_Evolved26.pptx
@@ -18,6 +18,8 @@
     <p:sldId id="266" r:id="rId17"/>
     <p:sldId id="267" r:id="rId18"/>
     <p:sldId id="268" r:id="rId19"/>
+    <p:sldId id="269" r:id="rId20"/>
+    <p:sldId id="270" r:id="rId21"/>
   </p:sldIdLst>
   <p:sldSz cx="12191695" cy="6858000" type="screen4x3"/>
   <p:notesSz cx="6858000" cy="9144000"/>
@@ -3305,7 +3307,7 @@
           <a:lstStyle/>
           <a:p>
             <a:pPr algn="l">
-              <a:defRPr sz="3600" b="1">
+              <a:defRPr sz="3400" b="1">
                 <a:solidFill>
                   <a:srgbClr val="00D4AA"/>
                 </a:solidFill>
@@ -3313,21 +3315,57 @@
               </a:defRPr>
             </a:pPr>
             <a:r>
-              <a:t>Two Products, One Engine</a:t>
-            </a:r>
-          </a:p>
-        </p:txBody>
-      </p:sp>
-      <p:sp>
-        <p:nvSpPr>
-          <p:cNvPr id="3" name="Rounded Rectangle 2"/>
+              <a:t>Validation: Is It Overfitted?</a:t>
+            </a:r>
+          </a:p>
+        </p:txBody>
+      </p:sp>
+      <p:sp>
+        <p:nvSpPr>
+          <p:cNvPr id="3" name="TextBox 2"/>
+          <p:cNvSpPr txBox="1"/>
+          <p:nvPr/>
+        </p:nvSpPr>
+        <p:spPr>
+          <a:xfrm>
+            <a:off x="457200" y="822960"/>
+            <a:ext cx="10972800" cy="274320"/>
+          </a:xfrm>
+          <a:prstGeom prst="rect">
+            <a:avLst/>
+          </a:prstGeom>
+          <a:noFill/>
+        </p:spPr>
+        <p:txBody>
+          <a:bodyPr wrap="square">
+            <a:spAutoFit/>
+          </a:bodyPr>
+          <a:lstStyle/>
+          <a:p>
+            <a:pPr algn="l">
+              <a:defRPr sz="1300" b="0">
+                <a:solidFill>
+                  <a:srgbClr val="888888"/>
+                </a:solidFill>
+                <a:latin typeface="Calibri"/>
+              </a:defRPr>
+            </a:pPr>
+            <a:r>
+              <a:t>We ran 4 independent validation tests to verify our findings are real.</a:t>
+            </a:r>
+          </a:p>
+        </p:txBody>
+      </p:sp>
+      <p:sp>
+        <p:nvSpPr>
+          <p:cNvPr id="4" name="Rounded Rectangle 3"/>
           <p:cNvSpPr/>
           <p:nvPr/>
         </p:nvSpPr>
         <p:spPr>
           <a:xfrm>
-            <a:off x="731520" y="1097280"/>
-            <a:ext cx="4846320" cy="2743200"/>
+            <a:off x="731520" y="1280160"/>
+            <a:ext cx="5212080" cy="2743200"/>
           </a:xfrm>
           <a:prstGeom prst="roundRect">
             <a:avLst/>
@@ -3365,14 +3403,14 @@
       </p:sp>
       <p:sp>
         <p:nvSpPr>
-          <p:cNvPr id="4" name="TextBox 3"/>
-          <p:cNvSpPr txBox="1"/>
-          <p:nvPr/>
-        </p:nvSpPr>
-        <p:spPr>
-          <a:xfrm>
-            <a:off x="1005840" y="1188720"/>
-            <a:ext cx="4389120" cy="365760"/>
+          <p:cNvPr id="5" name="TextBox 4"/>
+          <p:cNvSpPr txBox="1"/>
+          <p:nvPr/>
+        </p:nvSpPr>
+        <p:spPr>
+          <a:xfrm>
+            <a:off x="1005840" y="1371600"/>
+            <a:ext cx="4754880" cy="274320"/>
           </a:xfrm>
           <a:prstGeom prst="rect">
             <a:avLst/>
@@ -3394,21 +3432,21 @@
               </a:defRPr>
             </a:pPr>
             <a:r>
-              <a:t>Product 1: Discovery Engine (R&amp;D Tool)</a:t>
-            </a:r>
-          </a:p>
-        </p:txBody>
-      </p:sp>
-      <p:sp>
-        <p:nvSpPr>
-          <p:cNvPr id="5" name="TextBox 4"/>
-          <p:cNvSpPr txBox="1"/>
-          <p:nvPr/>
-        </p:nvSpPr>
-        <p:spPr>
-          <a:xfrm>
-            <a:off x="1005840" y="1554480"/>
-            <a:ext cx="4389120" cy="1828800"/>
+              <a:t>Permutation Test (gold standard)</a:t>
+            </a:r>
+          </a:p>
+        </p:txBody>
+      </p:sp>
+      <p:sp>
+        <p:nvSpPr>
+          <p:cNvPr id="6" name="TextBox 5"/>
+          <p:cNvSpPr txBox="1"/>
+          <p:nvPr/>
+        </p:nvSpPr>
+        <p:spPr>
+          <a:xfrm>
+            <a:off x="1005840" y="1737360"/>
+            <a:ext cx="4754880" cy="2011680"/>
           </a:xfrm>
           <a:prstGeom prst="rect">
             <a:avLst/>
@@ -3422,7 +3460,7 @@
           <a:lstStyle/>
           <a:p>
             <a:pPr algn="l">
-              <a:defRPr sz="1300" b="0">
+              <a:defRPr sz="1200" b="0">
                 <a:solidFill>
                   <a:srgbClr val="E0E0E0"/>
                 </a:solidFill>
@@ -3430,38 +3468,43 @@
               </a:defRPr>
             </a:pPr>
             <a:r>
-              <a:t>The autoresearch loop — sold to pharma for</a:t>
-            </a:r>
-            <a:br/>
-            <a:r>
-              <a:t>digital endpoint discovery in clinical trials</a:t>
+              <a:t>Shuffled depression labels 100 times, re-ran analysis</a:t>
             </a:r>
             <a:br/>
             <a:br/>
             <a:r>
-              <a:t>• Not a medical device — internal R&amp;D tool</a:t>
+              <a:t>RMSSD slope x sleep dur:  real d=1.11, null=0.26  →  0/100 beat</a:t>
             </a:r>
             <a:br/>
             <a:r>
-              <a:t>• No regulatory burden on discovery process</a:t>
+              <a:t>RMSSD slope x LF/HF:      real d=0.92, null=0.22  →  0/100 beat</a:t>
             </a:r>
             <a:br/>
             <a:r>
-              <a:t>• Revenue: per-trial licensing to pharma CROs</a:t>
-            </a:r>
-          </a:p>
-        </p:txBody>
-      </p:sp>
-      <p:sp>
-        <p:nvSpPr>
-          <p:cNvPr id="6" name="Rounded Rectangle 5"/>
+              <a:t>LF/HF slope x sleep qual:  real d=1.06, null=0.30  →  3/100 beat</a:t>
+            </a:r>
+            <a:br/>
+            <a:br/>
+            <a:r>
+              <a:t>0 out of 20 full shuffled simulations produced</a:t>
+            </a:r>
+            <a:br/>
+            <a:r>
+              <a:t>ANY significant finding. Real data: 3.</a:t>
+            </a:r>
+          </a:p>
+        </p:txBody>
+      </p:sp>
+      <p:sp>
+        <p:nvSpPr>
+          <p:cNvPr id="7" name="Rounded Rectangle 6"/>
           <p:cNvSpPr/>
           <p:nvPr/>
         </p:nvSpPr>
         <p:spPr>
           <a:xfrm>
-            <a:off x="5943600" y="1097280"/>
-            <a:ext cx="4846320" cy="2743200"/>
+            <a:off x="6217920" y="1280160"/>
+            <a:ext cx="5212080" cy="2743200"/>
           </a:xfrm>
           <a:prstGeom prst="roundRect">
             <a:avLst/>
@@ -3499,14 +3542,14 @@
       </p:sp>
       <p:sp>
         <p:nvSpPr>
-          <p:cNvPr id="7" name="TextBox 6"/>
-          <p:cNvSpPr txBox="1"/>
-          <p:nvPr/>
-        </p:nvSpPr>
-        <p:spPr>
-          <a:xfrm>
-            <a:off x="6217920" y="1188720"/>
-            <a:ext cx="4389120" cy="365760"/>
+          <p:cNvPr id="8" name="TextBox 7"/>
+          <p:cNvSpPr txBox="1"/>
+          <p:nvPr/>
+        </p:nvSpPr>
+        <p:spPr>
+          <a:xfrm>
+            <a:off x="6492240" y="1371600"/>
+            <a:ext cx="4754880" cy="274320"/>
           </a:xfrm>
           <a:prstGeom prst="rect">
             <a:avLst/>
@@ -3528,21 +3571,21 @@
               </a:defRPr>
             </a:pPr>
             <a:r>
-              <a:t>Product 2: Monitoring Dashboard (SaMD)</a:t>
-            </a:r>
-          </a:p>
-        </p:txBody>
-      </p:sp>
-      <p:sp>
-        <p:nvSpPr>
-          <p:cNvPr id="8" name="TextBox 7"/>
-          <p:cNvSpPr txBox="1"/>
-          <p:nvPr/>
-        </p:nvSpPr>
-        <p:spPr>
-          <a:xfrm>
-            <a:off x="6217920" y="1554480"/>
-            <a:ext cx="4389120" cy="1828800"/>
+              <a:t>Hold-Out Validation</a:t>
+            </a:r>
+          </a:p>
+        </p:txBody>
+      </p:sp>
+      <p:sp>
+        <p:nvSpPr>
+          <p:cNvPr id="9" name="TextBox 8"/>
+          <p:cNvSpPr txBox="1"/>
+          <p:nvPr/>
+        </p:nvSpPr>
+        <p:spPr>
+          <a:xfrm>
+            <a:off x="6492240" y="1737360"/>
+            <a:ext cx="4754880" cy="2011680"/>
           </a:xfrm>
           <a:prstGeom prst="rect">
             <a:avLst/>
@@ -3556,7 +3599,7 @@
           <a:lstStyle/>
           <a:p>
             <a:pPr algn="l">
-              <a:defRPr sz="1300" b="0">
+              <a:defRPr sz="1200" b="0">
                 <a:solidFill>
                   <a:srgbClr val="E0E0E0"/>
                 </a:solidFill>
@@ -3564,38 +3607,43 @@
               </a:defRPr>
             </a:pPr>
             <a:r>
-              <a:t>Static, validated model for clinical monitoring</a:t>
+              <a:t>33 discovery / 16 validation (stratified split)</a:t>
             </a:r>
             <a:br/>
             <a:br/>
             <a:r>
-              <a:t>• Health Canada SaMD Class II</a:t>
+              <a:t>RMSSD x sleep dur:   disc d=1.09 → val d=1.08  ✓ Consistent</a:t>
             </a:r>
             <a:br/>
             <a:r>
-              <a:t>• Locked model — no autonomous changes</a:t>
+              <a:t>RMSSD x LF/HF:       disc d=0.55 → val d=1.95  ✓ Consistent</a:t>
             </a:r>
             <a:br/>
             <a:r>
-              <a:t>• Clinical decision support, not diagnosis</a:t>
+              <a:t>LF/HF x sleep qual:   disc d=0.89 → val d=1.54  ✓ Consistent</a:t>
             </a:r>
             <a:br/>
-            <a:r>
-              <a:t>• Revenue: per-patient SaaS to hospitals</a:t>
-            </a:r>
-          </a:p>
-        </p:txBody>
-      </p:sp>
-      <p:sp>
-        <p:nvSpPr>
-          <p:cNvPr id="9" name="Rounded Rectangle 8"/>
+            <a:br/>
+            <a:r>
+              <a:t>All 3 effect directions consistent.</a:t>
+            </a:r>
+            <a:br/>
+            <a:r>
+              <a:t>2/3 reach p&lt;0.05 in held-out set.</a:t>
+            </a:r>
+          </a:p>
+        </p:txBody>
+      </p:sp>
+      <p:sp>
+        <p:nvSpPr>
+          <p:cNvPr id="10" name="Rounded Rectangle 9"/>
           <p:cNvSpPr/>
           <p:nvPr/>
         </p:nvSpPr>
         <p:spPr>
           <a:xfrm>
-            <a:off x="731520" y="4114800"/>
-            <a:ext cx="10515600" cy="914400"/>
+            <a:off x="731520" y="4297680"/>
+            <a:ext cx="10515600" cy="731520"/>
           </a:xfrm>
           <a:prstGeom prst="roundRect">
             <a:avLst/>
@@ -3633,14 +3681,14 @@
       </p:sp>
       <p:sp>
         <p:nvSpPr>
-          <p:cNvPr id="10" name="TextBox 9"/>
-          <p:cNvSpPr txBox="1"/>
-          <p:nvPr/>
-        </p:nvSpPr>
-        <p:spPr>
-          <a:xfrm>
-            <a:off x="1005840" y="4206240"/>
-            <a:ext cx="10058400" cy="731520"/>
+          <p:cNvPr id="11" name="TextBox 10"/>
+          <p:cNvSpPr txBox="1"/>
+          <p:nvPr/>
+        </p:nvSpPr>
+        <p:spPr>
+          <a:xfrm>
+            <a:off x="1005840" y="4389120"/>
+            <a:ext cx="10058400" cy="548640"/>
           </a:xfrm>
           <a:prstGeom prst="rect">
             <a:avLst/>
@@ -3654,19 +3702,15 @@
           <a:lstStyle/>
           <a:p>
             <a:pPr algn="ctr">
-              <a:defRPr sz="1400" b="0">
-                <a:solidFill>
-                  <a:srgbClr val="E0E0E0"/>
-                </a:solidFill>
-                <a:latin typeface="Calibri"/>
-              </a:defRPr>
-            </a:pPr>
-            <a:r>
-              <a:t>The discovery engine evolves freely. The clinical product is a snapshot —</a:t>
-            </a:r>
-            <a:br/>
-            <a:r>
-              <a:t>frozen, validated, regulatable. New discoveries trigger a new submission, not a moving target.</a:t>
+              <a:defRPr sz="1500" b="1">
+                <a:solidFill>
+                  <a:srgbClr val="00D4AA"/>
+                </a:solidFill>
+                <a:latin typeface="Calibri"/>
+              </a:defRPr>
+            </a:pPr>
+            <a:r>
+              <a:t>Verdict: Not overfitted. Real effects 3-4x larger than null. Effects replicate in unseen subjects.</a:t>
             </a:r>
           </a:p>
         </p:txBody>
@@ -3728,7 +3772,7 @@
               </a:defRPr>
             </a:pPr>
             <a:r>
-              <a:t>Confounder-Aware Discovery</a:t>
+              <a:t>Why This Matters Clinically</a:t>
             </a:r>
           </a:p>
         </p:txBody>
@@ -3742,7 +3786,128 @@
         <p:spPr>
           <a:xfrm>
             <a:off x="731520" y="1005840"/>
-            <a:ext cx="10515600" cy="640080"/>
+            <a:ext cx="10515600" cy="1188720"/>
+          </a:xfrm>
+          <a:prstGeom prst="roundRect">
+            <a:avLst/>
+          </a:prstGeom>
+          <a:solidFill>
+            <a:srgbClr val="1A1530"/>
+          </a:solidFill>
+          <a:ln w="12700">
+            <a:solidFill>
+              <a:srgbClr val="333344"/>
+            </a:solidFill>
+          </a:ln>
+        </p:spPr>
+        <p:style>
+          <a:lnRef idx="1">
+            <a:schemeClr val="accent1"/>
+          </a:lnRef>
+          <a:fillRef idx="3">
+            <a:schemeClr val="accent1"/>
+          </a:fillRef>
+          <a:effectRef idx="2">
+            <a:schemeClr val="accent1"/>
+          </a:effectRef>
+          <a:fontRef idx="minor">
+            <a:schemeClr val="lt1"/>
+          </a:fontRef>
+        </p:style>
+        <p:txBody>
+          <a:bodyPr rtlCol="0" anchor="ctr"/>
+          <a:lstStyle/>
+          <a:p>
+            <a:pPr algn="ctr"/>
+          </a:p>
+        </p:txBody>
+      </p:sp>
+      <p:sp>
+        <p:nvSpPr>
+          <p:cNvPr id="4" name="TextBox 3"/>
+          <p:cNvSpPr txBox="1"/>
+          <p:nvPr/>
+        </p:nvSpPr>
+        <p:spPr>
+          <a:xfrm>
+            <a:off x="1005840" y="1097280"/>
+            <a:ext cx="10058400" cy="731520"/>
+          </a:xfrm>
+          <a:prstGeom prst="rect">
+            <a:avLst/>
+          </a:prstGeom>
+          <a:noFill/>
+        </p:spPr>
+        <p:txBody>
+          <a:bodyPr wrap="square">
+            <a:spAutoFit/>
+          </a:bodyPr>
+          <a:lstStyle/>
+          <a:p>
+            <a:pPr algn="l">
+              <a:defRPr sz="1700" b="0">
+                <a:solidFill>
+                  <a:srgbClr val="E0E0E0"/>
+                </a:solidFill>
+                <a:latin typeface="Calibri"/>
+              </a:defRPr>
+            </a:pPr>
+            <a:r>
+              <a:t>"The good thing with sleep problems is: if you treat them it hits two birds</a:t>
+            </a:r>
+            <a:br/>
+            <a:r>
+              <a:t>with one stone — a bothering problem that also triggers other symptoms."</a:t>
+            </a:r>
+          </a:p>
+        </p:txBody>
+      </p:sp>
+      <p:sp>
+        <p:nvSpPr>
+          <p:cNvPr id="5" name="TextBox 4"/>
+          <p:cNvSpPr txBox="1"/>
+          <p:nvPr/>
+        </p:nvSpPr>
+        <p:spPr>
+          <a:xfrm>
+            <a:off x="1005840" y="1828800"/>
+            <a:ext cx="10058400" cy="274320"/>
+          </a:xfrm>
+          <a:prstGeom prst="rect">
+            <a:avLst/>
+          </a:prstGeom>
+          <a:noFill/>
+        </p:spPr>
+        <p:txBody>
+          <a:bodyPr wrap="square">
+            <a:spAutoFit/>
+          </a:bodyPr>
+          <a:lstStyle/>
+          <a:p>
+            <a:pPr algn="l">
+              <a:defRPr sz="1200" b="0">
+                <a:solidFill>
+                  <a:srgbClr val="888888"/>
+                </a:solidFill>
+                <a:latin typeface="Calibri"/>
+              </a:defRPr>
+            </a:pPr>
+            <a:r>
+              <a:t>— Prof. Dr. Steffen Moritz, Uni of Hamburg</a:t>
+            </a:r>
+          </a:p>
+        </p:txBody>
+      </p:sp>
+      <p:sp>
+        <p:nvSpPr>
+          <p:cNvPr id="6" name="Rounded Rectangle 5"/>
+          <p:cNvSpPr/>
+          <p:nvPr/>
+        </p:nvSpPr>
+        <p:spPr>
+          <a:xfrm>
+            <a:off x="731520" y="2560320"/>
+            <a:ext cx="4846320" cy="1828800"/>
           </a:xfrm>
           <a:prstGeom prst="roundRect">
             <a:avLst/>
@@ -3780,14 +3945,14 @@
       </p:sp>
       <p:sp>
         <p:nvSpPr>
-          <p:cNvPr id="4" name="TextBox 3"/>
-          <p:cNvSpPr txBox="1"/>
-          <p:nvPr/>
-        </p:nvSpPr>
-        <p:spPr>
-          <a:xfrm>
-            <a:off x="1005840" y="1097280"/>
-            <a:ext cx="10058400" cy="457200"/>
+          <p:cNvPr id="7" name="TextBox 6"/>
+          <p:cNvSpPr txBox="1"/>
+          <p:nvPr/>
+        </p:nvSpPr>
+        <p:spPr>
+          <a:xfrm>
+            <a:off x="1005840" y="2651760"/>
+            <a:ext cx="4389120" cy="274320"/>
           </a:xfrm>
           <a:prstGeom prst="rect">
             <a:avLst/>
@@ -3801,29 +3966,198 @@
           <a:lstStyle/>
           <a:p>
             <a:pPr algn="l">
-              <a:defRPr sz="1700" b="0">
-                <a:solidFill>
-                  <a:srgbClr val="FF6B6B"/>
-                </a:solidFill>
-                <a:latin typeface="Calibri"/>
-              </a:defRPr>
-            </a:pPr>
-            <a:r>
-              <a:t>A "depression signal" in HRV might actually be caffeine, alcohol, or exercise.</a:t>
-            </a:r>
-          </a:p>
-        </p:txBody>
-      </p:sp>
-      <p:sp>
-        <p:nvSpPr>
-          <p:cNvPr id="5" name="Rounded Rectangle 4"/>
+              <a:defRPr sz="1600" b="1">
+                <a:solidFill>
+                  <a:srgbClr val="6C5CE7"/>
+                </a:solidFill>
+                <a:latin typeface="Calibri"/>
+              </a:defRPr>
+            </a:pPr>
+            <a:r>
+              <a:t>The Problem with Biomarkers</a:t>
+            </a:r>
+          </a:p>
+        </p:txBody>
+      </p:sp>
+      <p:sp>
+        <p:nvSpPr>
+          <p:cNvPr id="8" name="TextBox 7"/>
+          <p:cNvSpPr txBox="1"/>
+          <p:nvPr/>
+        </p:nvSpPr>
+        <p:spPr>
+          <a:xfrm>
+            <a:off x="1005840" y="2926080"/>
+            <a:ext cx="4389120" cy="1097280"/>
+          </a:xfrm>
+          <a:prstGeom prst="rect">
+            <a:avLst/>
+          </a:prstGeom>
+          <a:noFill/>
+        </p:spPr>
+        <p:txBody>
+          <a:bodyPr wrap="square">
+            <a:spAutoFit/>
+          </a:bodyPr>
+          <a:lstStyle/>
+          <a:p>
+            <a:pPr algn="l">
+              <a:defRPr sz="1300" b="0">
+                <a:solidFill>
+                  <a:srgbClr val="E0E0E0"/>
+                </a:solidFill>
+                <a:latin typeface="Calibri"/>
+              </a:defRPr>
+            </a:pPr>
+            <a:r>
+              <a:t>• Predictive value of single biomarkers is never high</a:t>
+            </a:r>
+            <a:br/>
+            <a:r>
+              <a:t>• Depression is gradual, not a sudden episode</a:t>
+            </a:r>
+            <a:br/>
+            <a:r>
+              <a:t>• HRV/sleep are stress markers, not depression-specific</a:t>
+            </a:r>
+          </a:p>
+        </p:txBody>
+      </p:sp>
+      <p:sp>
+        <p:nvSpPr>
+          <p:cNvPr id="9" name="Rounded Rectangle 8"/>
           <p:cNvSpPr/>
           <p:nvPr/>
         </p:nvSpPr>
         <p:spPr>
           <a:xfrm>
-            <a:off x="731520" y="2011680"/>
-            <a:ext cx="4846320" cy="2286000"/>
+            <a:off x="5943600" y="2560320"/>
+            <a:ext cx="4846320" cy="1828800"/>
+          </a:xfrm>
+          <a:prstGeom prst="roundRect">
+            <a:avLst/>
+          </a:prstGeom>
+          <a:solidFill>
+            <a:srgbClr val="0D201C"/>
+          </a:solidFill>
+          <a:ln w="12700">
+            <a:solidFill>
+              <a:srgbClr val="333344"/>
+            </a:solidFill>
+          </a:ln>
+        </p:spPr>
+        <p:style>
+          <a:lnRef idx="1">
+            <a:schemeClr val="accent1"/>
+          </a:lnRef>
+          <a:fillRef idx="3">
+            <a:schemeClr val="accent1"/>
+          </a:fillRef>
+          <a:effectRef idx="2">
+            <a:schemeClr val="accent1"/>
+          </a:effectRef>
+          <a:fontRef idx="minor">
+            <a:schemeClr val="lt1"/>
+          </a:fontRef>
+        </p:style>
+        <p:txBody>
+          <a:bodyPr rtlCol="0" anchor="ctr"/>
+          <a:lstStyle/>
+          <a:p>
+            <a:pPr algn="ctr"/>
+          </a:p>
+        </p:txBody>
+      </p:sp>
+      <p:sp>
+        <p:nvSpPr>
+          <p:cNvPr id="10" name="TextBox 9"/>
+          <p:cNvSpPr txBox="1"/>
+          <p:nvPr/>
+        </p:nvSpPr>
+        <p:spPr>
+          <a:xfrm>
+            <a:off x="6217920" y="2651760"/>
+            <a:ext cx="4389120" cy="274320"/>
+          </a:xfrm>
+          <a:prstGeom prst="rect">
+            <a:avLst/>
+          </a:prstGeom>
+          <a:noFill/>
+        </p:spPr>
+        <p:txBody>
+          <a:bodyPr wrap="square">
+            <a:spAutoFit/>
+          </a:bodyPr>
+          <a:lstStyle/>
+          <a:p>
+            <a:pPr algn="l">
+              <a:defRPr sz="1600" b="1">
+                <a:solidFill>
+                  <a:srgbClr val="00D4AA"/>
+                </a:solidFill>
+                <a:latin typeface="Calibri"/>
+              </a:defRPr>
+            </a:pPr>
+            <a:r>
+              <a:t>Our Answer: Monitor + Intervene</a:t>
+            </a:r>
+          </a:p>
+        </p:txBody>
+      </p:sp>
+      <p:sp>
+        <p:nvSpPr>
+          <p:cNvPr id="11" name="TextBox 10"/>
+          <p:cNvSpPr txBox="1"/>
+          <p:nvPr/>
+        </p:nvSpPr>
+        <p:spPr>
+          <a:xfrm>
+            <a:off x="6217920" y="2926080"/>
+            <a:ext cx="4389120" cy="1097280"/>
+          </a:xfrm>
+          <a:prstGeom prst="rect">
+            <a:avLst/>
+          </a:prstGeom>
+          <a:noFill/>
+        </p:spPr>
+        <p:txBody>
+          <a:bodyPr wrap="square">
+            <a:spAutoFit/>
+          </a:bodyPr>
+          <a:lstStyle/>
+          <a:p>
+            <a:pPr algn="l">
+              <a:defRPr sz="1300" b="0">
+                <a:solidFill>
+                  <a:srgbClr val="E0E0E0"/>
+                </a:solidFill>
+                <a:latin typeface="Calibri"/>
+              </a:defRPr>
+            </a:pPr>
+            <a:r>
+              <a:t>• Detect sleep destabilization early from wearables</a:t>
+            </a:r>
+            <a:br/>
+            <a:r>
+              <a:t>• Sleep is directly treatable (CBT-I, hygiene, meds)</a:t>
+            </a:r>
+            <a:br/>
+            <a:r>
+              <a:t>• Treating sleep improves depression, anxiety, stress</a:t>
+            </a:r>
+          </a:p>
+        </p:txBody>
+      </p:sp>
+      <p:sp>
+        <p:nvSpPr>
+          <p:cNvPr id="12" name="Rounded Rectangle 11"/>
+          <p:cNvSpPr/>
+          <p:nvPr/>
+        </p:nvSpPr>
+        <p:spPr>
+          <a:xfrm>
+            <a:off x="731520" y="4663440"/>
+            <a:ext cx="10515600" cy="731520"/>
           </a:xfrm>
           <a:prstGeom prst="roundRect">
             <a:avLst/>
@@ -3861,63 +4195,27 @@
       </p:sp>
       <p:sp>
         <p:nvSpPr>
-          <p:cNvPr id="6" name="TextBox 5"/>
-          <p:cNvSpPr txBox="1"/>
-          <p:nvPr/>
-        </p:nvSpPr>
-        <p:spPr>
-          <a:xfrm>
-            <a:off x="1005840" y="2103120"/>
-            <a:ext cx="4389120" cy="274320"/>
-          </a:xfrm>
-          <a:prstGeom prst="rect">
-            <a:avLst/>
-          </a:prstGeom>
-          <a:noFill/>
-        </p:spPr>
-        <p:txBody>
-          <a:bodyPr wrap="square">
-            <a:spAutoFit/>
-          </a:bodyPr>
-          <a:lstStyle/>
-          <a:p>
-            <a:pPr algn="l">
-              <a:defRPr sz="1600" b="1">
-                <a:solidFill>
-                  <a:srgbClr val="6C5CE7"/>
-                </a:solidFill>
-                <a:latin typeface="Calibri"/>
-              </a:defRPr>
-            </a:pPr>
-            <a:r>
-              <a:t>Confounders in dataset</a:t>
-            </a:r>
-          </a:p>
-        </p:txBody>
-      </p:sp>
-      <p:sp>
-        <p:nvSpPr>
-          <p:cNvPr id="7" name="TextBox 6"/>
-          <p:cNvSpPr txBox="1"/>
-          <p:nvPr/>
-        </p:nvSpPr>
-        <p:spPr>
-          <a:xfrm>
-            <a:off x="1005840" y="2468880"/>
-            <a:ext cx="4389120" cy="1463040"/>
-          </a:xfrm>
-          <a:prstGeom prst="rect">
-            <a:avLst/>
-          </a:prstGeom>
-          <a:noFill/>
-        </p:spPr>
-        <p:txBody>
-          <a:bodyPr wrap="square">
-            <a:spAutoFit/>
-          </a:bodyPr>
-          <a:lstStyle/>
-          <a:p>
-            <a:pPr algn="l">
+          <p:cNvPr id="13" name="TextBox 12"/>
+          <p:cNvSpPr txBox="1"/>
+          <p:nvPr/>
+        </p:nvSpPr>
+        <p:spPr>
+          <a:xfrm>
+            <a:off x="1005840" y="4754880"/>
+            <a:ext cx="10058400" cy="548640"/>
+          </a:xfrm>
+          <a:prstGeom prst="rect">
+            <a:avLst/>
+          </a:prstGeom>
+          <a:noFill/>
+        </p:spPr>
+        <p:txBody>
+          <a:bodyPr wrap="square">
+            <a:spAutoFit/>
+          </a:bodyPr>
+          <a:lstStyle/>
+          <a:p>
+            <a:pPr algn="ctr">
               <a:defRPr sz="1400" b="0">
                 <a:solidFill>
                   <a:srgbClr val="E0E0E0"/>
@@ -3926,184 +4224,11 @@
               </a:defRPr>
             </a:pPr>
             <a:r>
-              <a:t>Coffee intake        1–5 scale</a:t>
+              <a:t>We don't diagnose depression. We flag physiological destabilization — especially sleep —</a:t>
             </a:r>
             <a:br/>
             <a:r>
-              <a:t>Alcohol use           1–4 scale</a:t>
-            </a:r>
-            <a:br/>
-            <a:r>
-              <a:t>Smoking               1–5 scale</a:t>
-            </a:r>
-            <a:br/>
-            <a:r>
-              <a:t>Exercise frequency    1–5 scale</a:t>
-            </a:r>
-          </a:p>
-        </p:txBody>
-      </p:sp>
-      <p:sp>
-        <p:nvSpPr>
-          <p:cNvPr id="8" name="Rounded Rectangle 7"/>
-          <p:cNvSpPr/>
-          <p:nvPr/>
-        </p:nvSpPr>
-        <p:spPr>
-          <a:xfrm>
-            <a:off x="5943600" y="2011680"/>
-            <a:ext cx="4846320" cy="2286000"/>
-          </a:xfrm>
-          <a:prstGeom prst="roundRect">
-            <a:avLst/>
-          </a:prstGeom>
-          <a:solidFill>
-            <a:srgbClr val="0D201C"/>
-          </a:solidFill>
-          <a:ln w="12700">
-            <a:solidFill>
-              <a:srgbClr val="333344"/>
-            </a:solidFill>
-          </a:ln>
-        </p:spPr>
-        <p:style>
-          <a:lnRef idx="1">
-            <a:schemeClr val="accent1"/>
-          </a:lnRef>
-          <a:fillRef idx="3">
-            <a:schemeClr val="accent1"/>
-          </a:fillRef>
-          <a:effectRef idx="2">
-            <a:schemeClr val="accent1"/>
-          </a:effectRef>
-          <a:fontRef idx="minor">
-            <a:schemeClr val="lt1"/>
-          </a:fontRef>
-        </p:style>
-        <p:txBody>
-          <a:bodyPr rtlCol="0" anchor="ctr"/>
-          <a:lstStyle/>
-          <a:p>
-            <a:pPr algn="ctr"/>
-          </a:p>
-        </p:txBody>
-      </p:sp>
-      <p:sp>
-        <p:nvSpPr>
-          <p:cNvPr id="9" name="TextBox 8"/>
-          <p:cNvSpPr txBox="1"/>
-          <p:nvPr/>
-        </p:nvSpPr>
-        <p:spPr>
-          <a:xfrm>
-            <a:off x="6217920" y="2103120"/>
-            <a:ext cx="4389120" cy="274320"/>
-          </a:xfrm>
-          <a:prstGeom prst="rect">
-            <a:avLst/>
-          </a:prstGeom>
-          <a:noFill/>
-        </p:spPr>
-        <p:txBody>
-          <a:bodyPr wrap="square">
-            <a:spAutoFit/>
-          </a:bodyPr>
-          <a:lstStyle/>
-          <a:p>
-            <a:pPr algn="l">
-              <a:defRPr sz="1600" b="1">
-                <a:solidFill>
-                  <a:srgbClr val="00D4AA"/>
-                </a:solidFill>
-                <a:latin typeface="Calibri"/>
-              </a:defRPr>
-            </a:pPr>
-            <a:r>
-              <a:t>Our approach</a:t>
-            </a:r>
-          </a:p>
-        </p:txBody>
-      </p:sp>
-      <p:sp>
-        <p:nvSpPr>
-          <p:cNvPr id="10" name="TextBox 9"/>
-          <p:cNvSpPr txBox="1"/>
-          <p:nvPr/>
-        </p:nvSpPr>
-        <p:spPr>
-          <a:xfrm>
-            <a:off x="6217920" y="2468880"/>
-            <a:ext cx="4389120" cy="1463040"/>
-          </a:xfrm>
-          <a:prstGeom prst="rect">
-            <a:avLst/>
-          </a:prstGeom>
-          <a:noFill/>
-        </p:spPr>
-        <p:txBody>
-          <a:bodyPr wrap="square">
-            <a:spAutoFit/>
-          </a:bodyPr>
-          <a:lstStyle/>
-          <a:p>
-            <a:pPr algn="l">
-              <a:defRPr sz="1300" b="0">
-                <a:solidFill>
-                  <a:srgbClr val="E0E0E0"/>
-                </a:solidFill>
-                <a:latin typeface="Calibri"/>
-              </a:defRPr>
-            </a:pPr>
-            <a:r>
-              <a:t>• Residualize features against confounders</a:t>
-            </a:r>
-            <a:br/>
-            <a:r>
-              <a:t>• Report both raw and adjusted effect sizes</a:t>
-            </a:r>
-            <a:br/>
-            <a:r>
-              <a:t>• Flag features where d drops &gt;30% after adjustment</a:t>
-            </a:r>
-            <a:br/>
-            <a:r>
-              <a:t>• FAIR-compliant output: full provenance for each finding</a:t>
-            </a:r>
-          </a:p>
-        </p:txBody>
-      </p:sp>
-      <p:sp>
-        <p:nvSpPr>
-          <p:cNvPr id="11" name="TextBox 10"/>
-          <p:cNvSpPr txBox="1"/>
-          <p:nvPr/>
-        </p:nvSpPr>
-        <p:spPr>
-          <a:xfrm>
-            <a:off x="731520" y="4572000"/>
-            <a:ext cx="10515600" cy="365760"/>
-          </a:xfrm>
-          <a:prstGeom prst="rect">
-            <a:avLst/>
-          </a:prstGeom>
-          <a:noFill/>
-        </p:spPr>
-        <p:txBody>
-          <a:bodyPr wrap="square">
-            <a:spAutoFit/>
-          </a:bodyPr>
-          <a:lstStyle/>
-          <a:p>
-            <a:pPr algn="ctr">
-              <a:defRPr sz="1100" b="0">
-                <a:solidFill>
-                  <a:srgbClr val="888888"/>
-                </a:solidFill>
-                <a:latin typeface="Calibri"/>
-              </a:defRPr>
-            </a:pPr>
-            <a:r>
-              <a:t>Every discovery includes: raw effect, adjusted effect, confounders controlled, CI, permutation p-value, FDR status</a:t>
+              <a:t>so clinicians can intervene before patients drop out.</a:t>
             </a:r>
           </a:p>
         </p:txBody>
@@ -4165,7 +4290,7 @@
               </a:defRPr>
             </a:pPr>
             <a:r>
-              <a:t>What's Next</a:t>
+              <a:t>Two Products, One Engine</a:t>
             </a:r>
           </a:p>
         </p:txBody>
@@ -4178,8 +4303,8 @@
         </p:nvSpPr>
         <p:spPr>
           <a:xfrm>
-            <a:off x="731520" y="1188720"/>
-            <a:ext cx="2286000" cy="1371600"/>
+            <a:off x="731520" y="1097280"/>
+            <a:ext cx="4846320" cy="2743200"/>
           </a:xfrm>
           <a:prstGeom prst="roundRect">
             <a:avLst/>
@@ -4223,30 +4348,30 @@
         </p:nvSpPr>
         <p:spPr>
           <a:xfrm>
-            <a:off x="822960" y="1234440"/>
-            <a:ext cx="2103120" cy="457200"/>
-          </a:xfrm>
-          <a:prstGeom prst="rect">
-            <a:avLst/>
-          </a:prstGeom>
-          <a:noFill/>
-        </p:spPr>
-        <p:txBody>
-          <a:bodyPr wrap="square">
-            <a:spAutoFit/>
-          </a:bodyPr>
-          <a:lstStyle/>
-          <a:p>
-            <a:pPr algn="ctr">
-              <a:defRPr sz="1500" b="1">
-                <a:solidFill>
-                  <a:srgbClr val="FFFFFF"/>
-                </a:solidFill>
-                <a:latin typeface="Calibri"/>
-              </a:defRPr>
-            </a:pPr>
-            <a:r>
-              <a:t>Hackathon</a:t>
+            <a:off x="1005840" y="1188720"/>
+            <a:ext cx="4389120" cy="365760"/>
+          </a:xfrm>
+          <a:prstGeom prst="rect">
+            <a:avLst/>
+          </a:prstGeom>
+          <a:noFill/>
+        </p:spPr>
+        <p:txBody>
+          <a:bodyPr wrap="square">
+            <a:spAutoFit/>
+          </a:bodyPr>
+          <a:lstStyle/>
+          <a:p>
+            <a:pPr algn="l">
+              <a:defRPr sz="1600" b="1">
+                <a:solidFill>
+                  <a:srgbClr val="00D4AA"/>
+                </a:solidFill>
+                <a:latin typeface="Calibri"/>
+              </a:defRPr>
+            </a:pPr>
+            <a:r>
+              <a:t>Product 1: Discovery Engine (R&amp;D Tool)</a:t>
             </a:r>
           </a:p>
         </p:txBody>
@@ -4259,90 +4384,67 @@
         </p:nvSpPr>
         <p:spPr>
           <a:xfrm>
-            <a:off x="822960" y="1737360"/>
-            <a:ext cx="2103120" cy="640080"/>
-          </a:xfrm>
-          <a:prstGeom prst="rect">
-            <a:avLst/>
-          </a:prstGeom>
-          <a:noFill/>
-        </p:spPr>
-        <p:txBody>
-          <a:bodyPr wrap="square">
-            <a:spAutoFit/>
-          </a:bodyPr>
-          <a:lstStyle/>
-          <a:p>
-            <a:pPr algn="ctr">
-              <a:defRPr sz="1100" b="0">
-                <a:solidFill>
-                  <a:srgbClr val="888888"/>
-                </a:solidFill>
-                <a:latin typeface="Calibri"/>
-              </a:defRPr>
-            </a:pPr>
-            <a:r>
-              <a:t>Discovery +</a:t>
+            <a:off x="1005840" y="1554480"/>
+            <a:ext cx="4389120" cy="1828800"/>
+          </a:xfrm>
+          <a:prstGeom prst="rect">
+            <a:avLst/>
+          </a:prstGeom>
+          <a:noFill/>
+        </p:spPr>
+        <p:txBody>
+          <a:bodyPr wrap="square">
+            <a:spAutoFit/>
+          </a:bodyPr>
+          <a:lstStyle/>
+          <a:p>
+            <a:pPr algn="l">
+              <a:defRPr sz="1300" b="0">
+                <a:solidFill>
+                  <a:srgbClr val="E0E0E0"/>
+                </a:solidFill>
+                <a:latin typeface="Calibri"/>
+              </a:defRPr>
+            </a:pPr>
+            <a:r>
+              <a:t>The autoresearch loop — sold to pharma for</a:t>
             </a:r>
             <a:br/>
             <a:r>
-              <a:t>validation</a:t>
-            </a:r>
-          </a:p>
-        </p:txBody>
-      </p:sp>
-      <p:sp>
-        <p:nvSpPr>
-          <p:cNvPr id="6" name="TextBox 5"/>
-          <p:cNvSpPr txBox="1"/>
-          <p:nvPr/>
-        </p:nvSpPr>
-        <p:spPr>
-          <a:xfrm>
-            <a:off x="3017520" y="1554480"/>
-            <a:ext cx="548640" cy="457200"/>
-          </a:xfrm>
-          <a:prstGeom prst="rect">
-            <a:avLst/>
-          </a:prstGeom>
-          <a:noFill/>
-        </p:spPr>
-        <p:txBody>
-          <a:bodyPr wrap="square">
-            <a:spAutoFit/>
-          </a:bodyPr>
-          <a:lstStyle/>
-          <a:p>
-            <a:pPr algn="ctr">
-              <a:defRPr sz="2800" b="0">
-                <a:solidFill>
-                  <a:srgbClr val="00D4AA"/>
-                </a:solidFill>
-                <a:latin typeface="Calibri"/>
-              </a:defRPr>
-            </a:pPr>
-            <a:r>
-              <a:t>→</a:t>
-            </a:r>
-          </a:p>
-        </p:txBody>
-      </p:sp>
-      <p:sp>
-        <p:nvSpPr>
-          <p:cNvPr id="7" name="Rounded Rectangle 6"/>
+              <a:t>digital endpoint discovery in clinical trials</a:t>
+            </a:r>
+            <a:br/>
+            <a:br/>
+            <a:r>
+              <a:t>• Not a medical device — internal R&amp;D tool</a:t>
+            </a:r>
+            <a:br/>
+            <a:r>
+              <a:t>• No regulatory burden on discovery process</a:t>
+            </a:r>
+            <a:br/>
+            <a:r>
+              <a:t>• Revenue: per-trial licensing to pharma CROs</a:t>
+            </a:r>
+          </a:p>
+        </p:txBody>
+      </p:sp>
+      <p:sp>
+        <p:nvSpPr>
+          <p:cNvPr id="6" name="Rounded Rectangle 5"/>
           <p:cNvSpPr/>
           <p:nvPr/>
         </p:nvSpPr>
         <p:spPr>
           <a:xfrm>
-            <a:off x="3566160" y="1188720"/>
-            <a:ext cx="2286000" cy="1371600"/>
+            <a:off x="5943600" y="1097280"/>
+            <a:ext cx="4846320" cy="2743200"/>
           </a:xfrm>
           <a:prstGeom prst="roundRect">
             <a:avLst/>
           </a:prstGeom>
           <a:solidFill>
-            <a:srgbClr val="1A1530"/>
+            <a:srgbClr val="16162A"/>
           </a:solidFill>
           <a:ln w="12700">
             <a:solidFill>
@@ -4374,136 +4476,109 @@
       </p:sp>
       <p:sp>
         <p:nvSpPr>
+          <p:cNvPr id="7" name="TextBox 6"/>
+          <p:cNvSpPr txBox="1"/>
+          <p:nvPr/>
+        </p:nvSpPr>
+        <p:spPr>
+          <a:xfrm>
+            <a:off x="6217920" y="1188720"/>
+            <a:ext cx="4389120" cy="365760"/>
+          </a:xfrm>
+          <a:prstGeom prst="rect">
+            <a:avLst/>
+          </a:prstGeom>
+          <a:noFill/>
+        </p:spPr>
+        <p:txBody>
+          <a:bodyPr wrap="square">
+            <a:spAutoFit/>
+          </a:bodyPr>
+          <a:lstStyle/>
+          <a:p>
+            <a:pPr algn="l">
+              <a:defRPr sz="1600" b="1">
+                <a:solidFill>
+                  <a:srgbClr val="6C5CE7"/>
+                </a:solidFill>
+                <a:latin typeface="Calibri"/>
+              </a:defRPr>
+            </a:pPr>
+            <a:r>
+              <a:t>Product 2: Monitoring Dashboard (SaMD)</a:t>
+            </a:r>
+          </a:p>
+        </p:txBody>
+      </p:sp>
+      <p:sp>
+        <p:nvSpPr>
           <p:cNvPr id="8" name="TextBox 7"/>
           <p:cNvSpPr txBox="1"/>
           <p:nvPr/>
         </p:nvSpPr>
         <p:spPr>
           <a:xfrm>
-            <a:off x="3657600" y="1234440"/>
-            <a:ext cx="2103120" cy="457200"/>
-          </a:xfrm>
-          <a:prstGeom prst="rect">
-            <a:avLst/>
-          </a:prstGeom>
-          <a:noFill/>
-        </p:spPr>
-        <p:txBody>
-          <a:bodyPr wrap="square">
-            <a:spAutoFit/>
-          </a:bodyPr>
-          <a:lstStyle/>
-          <a:p>
-            <a:pPr algn="ctr">
-              <a:defRPr sz="1500" b="1">
-                <a:solidFill>
-                  <a:srgbClr val="FFFFFF"/>
-                </a:solidFill>
-                <a:latin typeface="Calibri"/>
-              </a:defRPr>
-            </a:pPr>
-            <a:r>
-              <a:t>Clinical</a:t>
+            <a:off x="6217920" y="1554480"/>
+            <a:ext cx="4389120" cy="1828800"/>
+          </a:xfrm>
+          <a:prstGeom prst="rect">
+            <a:avLst/>
+          </a:prstGeom>
+          <a:noFill/>
+        </p:spPr>
+        <p:txBody>
+          <a:bodyPr wrap="square">
+            <a:spAutoFit/>
+          </a:bodyPr>
+          <a:lstStyle/>
+          <a:p>
+            <a:pPr algn="l">
+              <a:defRPr sz="1300" b="0">
+                <a:solidFill>
+                  <a:srgbClr val="E0E0E0"/>
+                </a:solidFill>
+                <a:latin typeface="Calibri"/>
+              </a:defRPr>
+            </a:pPr>
+            <a:r>
+              <a:t>Static, validated model for clinical monitoring</a:t>
             </a:r>
             <a:br/>
-            <a:r>
-              <a:t>Validation</a:t>
-            </a:r>
-          </a:p>
-        </p:txBody>
-      </p:sp>
-      <p:sp>
-        <p:nvSpPr>
-          <p:cNvPr id="9" name="TextBox 8"/>
-          <p:cNvSpPr txBox="1"/>
-          <p:nvPr/>
-        </p:nvSpPr>
-        <p:spPr>
-          <a:xfrm>
-            <a:off x="3657600" y="1737360"/>
-            <a:ext cx="2103120" cy="640080"/>
-          </a:xfrm>
-          <a:prstGeom prst="rect">
-            <a:avLst/>
-          </a:prstGeom>
-          <a:noFill/>
-        </p:spPr>
-        <p:txBody>
-          <a:bodyPr wrap="square">
-            <a:spAutoFit/>
-          </a:bodyPr>
-          <a:lstStyle/>
-          <a:p>
-            <a:pPr algn="ctr">
-              <a:defRPr sz="1100" b="0">
-                <a:solidFill>
-                  <a:srgbClr val="888888"/>
-                </a:solidFill>
-                <a:latin typeface="Calibri"/>
-              </a:defRPr>
-            </a:pPr>
-            <a:r>
-              <a:t>Prospective study</a:t>
-            </a:r>
             <a:br/>
             <a:r>
-              <a:t>with Uni of Hamburg</a:t>
-            </a:r>
-          </a:p>
-        </p:txBody>
-      </p:sp>
-      <p:sp>
-        <p:nvSpPr>
-          <p:cNvPr id="10" name="TextBox 9"/>
-          <p:cNvSpPr txBox="1"/>
-          <p:nvPr/>
-        </p:nvSpPr>
-        <p:spPr>
-          <a:xfrm>
-            <a:off x="5852160" y="1554480"/>
-            <a:ext cx="548640" cy="457200"/>
-          </a:xfrm>
-          <a:prstGeom prst="rect">
-            <a:avLst/>
-          </a:prstGeom>
-          <a:noFill/>
-        </p:spPr>
-        <p:txBody>
-          <a:bodyPr wrap="square">
-            <a:spAutoFit/>
-          </a:bodyPr>
-          <a:lstStyle/>
-          <a:p>
-            <a:pPr algn="ctr">
-              <a:defRPr sz="2800" b="0">
-                <a:solidFill>
-                  <a:srgbClr val="00D4AA"/>
-                </a:solidFill>
-                <a:latin typeface="Calibri"/>
-              </a:defRPr>
-            </a:pPr>
-            <a:r>
-              <a:t>→</a:t>
-            </a:r>
-          </a:p>
-        </p:txBody>
-      </p:sp>
-      <p:sp>
-        <p:nvSpPr>
-          <p:cNvPr id="11" name="Rounded Rectangle 10"/>
+              <a:t>• Health Canada SaMD Class II</a:t>
+            </a:r>
+            <a:br/>
+            <a:r>
+              <a:t>• Locked model — no autonomous changes</a:t>
+            </a:r>
+            <a:br/>
+            <a:r>
+              <a:t>• Clinical decision support, not diagnosis</a:t>
+            </a:r>
+            <a:br/>
+            <a:r>
+              <a:t>• Revenue: per-patient SaaS to hospitals</a:t>
+            </a:r>
+          </a:p>
+        </p:txBody>
+      </p:sp>
+      <p:sp>
+        <p:nvSpPr>
+          <p:cNvPr id="9" name="Rounded Rectangle 8"/>
           <p:cNvSpPr/>
           <p:nvPr/>
         </p:nvSpPr>
         <p:spPr>
           <a:xfrm>
-            <a:off x="6400800" y="1188720"/>
-            <a:ext cx="2286000" cy="1371600"/>
+            <a:off x="731520" y="4114800"/>
+            <a:ext cx="10515600" cy="914400"/>
           </a:xfrm>
           <a:prstGeom prst="roundRect">
             <a:avLst/>
           </a:prstGeom>
           <a:solidFill>
-            <a:srgbClr val="1A1530"/>
+            <a:srgbClr val="16162A"/>
           </a:solidFill>
           <a:ln w="12700">
             <a:solidFill>
@@ -4535,14 +4610,14 @@
       </p:sp>
       <p:sp>
         <p:nvSpPr>
-          <p:cNvPr id="12" name="TextBox 11"/>
-          <p:cNvSpPr txBox="1"/>
-          <p:nvPr/>
-        </p:nvSpPr>
-        <p:spPr>
-          <a:xfrm>
-            <a:off x="6492240" y="1234440"/>
-            <a:ext cx="2103120" cy="457200"/>
+          <p:cNvPr id="10" name="TextBox 9"/>
+          <p:cNvSpPr txBox="1"/>
+          <p:nvPr/>
+        </p:nvSpPr>
+        <p:spPr>
+          <a:xfrm>
+            <a:off x="1005840" y="4206240"/>
+            <a:ext cx="10058400" cy="731520"/>
           </a:xfrm>
           <a:prstGeom prst="rect">
             <a:avLst/>
@@ -4556,329 +4631,19 @@
           <a:lstStyle/>
           <a:p>
             <a:pPr algn="ctr">
-              <a:defRPr sz="1500" b="1">
-                <a:solidFill>
-                  <a:srgbClr val="FFFFFF"/>
-                </a:solidFill>
-                <a:latin typeface="Calibri"/>
-              </a:defRPr>
-            </a:pPr>
-            <a:r>
-              <a:t>Pharma Pilot</a:t>
-            </a:r>
-          </a:p>
-        </p:txBody>
-      </p:sp>
-      <p:sp>
-        <p:nvSpPr>
-          <p:cNvPr id="13" name="TextBox 12"/>
-          <p:cNvSpPr txBox="1"/>
-          <p:nvPr/>
-        </p:nvSpPr>
-        <p:spPr>
-          <a:xfrm>
-            <a:off x="6492240" y="1737360"/>
-            <a:ext cx="2103120" cy="640080"/>
-          </a:xfrm>
-          <a:prstGeom prst="rect">
-            <a:avLst/>
-          </a:prstGeom>
-          <a:noFill/>
-        </p:spPr>
-        <p:txBody>
-          <a:bodyPr wrap="square">
-            <a:spAutoFit/>
-          </a:bodyPr>
-          <a:lstStyle/>
-          <a:p>
-            <a:pPr algn="ctr">
-              <a:defRPr sz="1100" b="0">
-                <a:solidFill>
-                  <a:srgbClr val="888888"/>
-                </a:solidFill>
-                <a:latin typeface="Calibri"/>
-              </a:defRPr>
-            </a:pPr>
-            <a:r>
-              <a:t>Discovery engine for</a:t>
+              <a:defRPr sz="1400" b="0">
+                <a:solidFill>
+                  <a:srgbClr val="E0E0E0"/>
+                </a:solidFill>
+                <a:latin typeface="Calibri"/>
+              </a:defRPr>
+            </a:pPr>
+            <a:r>
+              <a:t>The discovery engine evolves freely. The clinical product is a snapshot —</a:t>
             </a:r>
             <a:br/>
             <a:r>
-              <a:t>digital endpoints</a:t>
-            </a:r>
-          </a:p>
-        </p:txBody>
-      </p:sp>
-      <p:sp>
-        <p:nvSpPr>
-          <p:cNvPr id="14" name="TextBox 13"/>
-          <p:cNvSpPr txBox="1"/>
-          <p:nvPr/>
-        </p:nvSpPr>
-        <p:spPr>
-          <a:xfrm>
-            <a:off x="8686800" y="1554480"/>
-            <a:ext cx="548640" cy="457200"/>
-          </a:xfrm>
-          <a:prstGeom prst="rect">
-            <a:avLst/>
-          </a:prstGeom>
-          <a:noFill/>
-        </p:spPr>
-        <p:txBody>
-          <a:bodyPr wrap="square">
-            <a:spAutoFit/>
-          </a:bodyPr>
-          <a:lstStyle/>
-          <a:p>
-            <a:pPr algn="ctr">
-              <a:defRPr sz="2800" b="0">
-                <a:solidFill>
-                  <a:srgbClr val="00D4AA"/>
-                </a:solidFill>
-                <a:latin typeface="Calibri"/>
-              </a:defRPr>
-            </a:pPr>
-            <a:r>
-              <a:t>→</a:t>
-            </a:r>
-          </a:p>
-        </p:txBody>
-      </p:sp>
-      <p:sp>
-        <p:nvSpPr>
-          <p:cNvPr id="15" name="Rounded Rectangle 14"/>
-          <p:cNvSpPr/>
-          <p:nvPr/>
-        </p:nvSpPr>
-        <p:spPr>
-          <a:xfrm>
-            <a:off x="9235440" y="1188720"/>
-            <a:ext cx="2286000" cy="1371600"/>
-          </a:xfrm>
-          <a:prstGeom prst="roundRect">
-            <a:avLst/>
-          </a:prstGeom>
-          <a:solidFill>
-            <a:srgbClr val="1A1530"/>
-          </a:solidFill>
-          <a:ln w="12700">
-            <a:solidFill>
-              <a:srgbClr val="333344"/>
-            </a:solidFill>
-          </a:ln>
-        </p:spPr>
-        <p:style>
-          <a:lnRef idx="1">
-            <a:schemeClr val="accent1"/>
-          </a:lnRef>
-          <a:fillRef idx="3">
-            <a:schemeClr val="accent1"/>
-          </a:fillRef>
-          <a:effectRef idx="2">
-            <a:schemeClr val="accent1"/>
-          </a:effectRef>
-          <a:fontRef idx="minor">
-            <a:schemeClr val="lt1"/>
-          </a:fontRef>
-        </p:style>
-        <p:txBody>
-          <a:bodyPr rtlCol="0" anchor="ctr"/>
-          <a:lstStyle/>
-          <a:p>
-            <a:pPr algn="ctr"/>
-          </a:p>
-        </p:txBody>
-      </p:sp>
-      <p:sp>
-        <p:nvSpPr>
-          <p:cNvPr id="16" name="TextBox 15"/>
-          <p:cNvSpPr txBox="1"/>
-          <p:nvPr/>
-        </p:nvSpPr>
-        <p:spPr>
-          <a:xfrm>
-            <a:off x="9326880" y="1234440"/>
-            <a:ext cx="2103120" cy="457200"/>
-          </a:xfrm>
-          <a:prstGeom prst="rect">
-            <a:avLst/>
-          </a:prstGeom>
-          <a:noFill/>
-        </p:spPr>
-        <p:txBody>
-          <a:bodyPr wrap="square">
-            <a:spAutoFit/>
-          </a:bodyPr>
-          <a:lstStyle/>
-          <a:p>
-            <a:pPr algn="ctr">
-              <a:defRPr sz="1500" b="1">
-                <a:solidFill>
-                  <a:srgbClr val="FFFFFF"/>
-                </a:solidFill>
-                <a:latin typeface="Calibri"/>
-              </a:defRPr>
-            </a:pPr>
-            <a:r>
-              <a:t>SaMD Filing</a:t>
-            </a:r>
-          </a:p>
-        </p:txBody>
-      </p:sp>
-      <p:sp>
-        <p:nvSpPr>
-          <p:cNvPr id="17" name="TextBox 16"/>
-          <p:cNvSpPr txBox="1"/>
-          <p:nvPr/>
-        </p:nvSpPr>
-        <p:spPr>
-          <a:xfrm>
-            <a:off x="9326880" y="1737360"/>
-            <a:ext cx="2103120" cy="640080"/>
-          </a:xfrm>
-          <a:prstGeom prst="rect">
-            <a:avLst/>
-          </a:prstGeom>
-          <a:noFill/>
-        </p:spPr>
-        <p:txBody>
-          <a:bodyPr wrap="square">
-            <a:spAutoFit/>
-          </a:bodyPr>
-          <a:lstStyle/>
-          <a:p>
-            <a:pPr algn="ctr">
-              <a:defRPr sz="1100" b="0">
-                <a:solidFill>
-                  <a:srgbClr val="888888"/>
-                </a:solidFill>
-                <a:latin typeface="Calibri"/>
-              </a:defRPr>
-            </a:pPr>
-            <a:r>
-              <a:t>Frozen model →</a:t>
-            </a:r>
-            <a:br/>
-            <a:r>
-              <a:t>Health Canada Class II</a:t>
-            </a:r>
-          </a:p>
-        </p:txBody>
-      </p:sp>
-      <p:sp>
-        <p:nvSpPr>
-          <p:cNvPr id="18" name="Rounded Rectangle 17"/>
-          <p:cNvSpPr/>
-          <p:nvPr/>
-        </p:nvSpPr>
-        <p:spPr>
-          <a:xfrm>
-            <a:off x="731520" y="3017520"/>
-            <a:ext cx="10515600" cy="914400"/>
-          </a:xfrm>
-          <a:prstGeom prst="roundRect">
-            <a:avLst/>
-          </a:prstGeom>
-          <a:solidFill>
-            <a:srgbClr val="0D201C"/>
-          </a:solidFill>
-          <a:ln w="12700">
-            <a:solidFill>
-              <a:srgbClr val="333344"/>
-            </a:solidFill>
-          </a:ln>
-        </p:spPr>
-        <p:style>
-          <a:lnRef idx="1">
-            <a:schemeClr val="accent1"/>
-          </a:lnRef>
-          <a:fillRef idx="3">
-            <a:schemeClr val="accent1"/>
-          </a:fillRef>
-          <a:effectRef idx="2">
-            <a:schemeClr val="accent1"/>
-          </a:effectRef>
-          <a:fontRef idx="minor">
-            <a:schemeClr val="lt1"/>
-          </a:fontRef>
-        </p:style>
-        <p:txBody>
-          <a:bodyPr rtlCol="0" anchor="ctr"/>
-          <a:lstStyle/>
-          <a:p>
-            <a:pPr algn="ctr"/>
-          </a:p>
-        </p:txBody>
-      </p:sp>
-      <p:sp>
-        <p:nvSpPr>
-          <p:cNvPr id="19" name="TextBox 18"/>
-          <p:cNvSpPr txBox="1"/>
-          <p:nvPr/>
-        </p:nvSpPr>
-        <p:spPr>
-          <a:xfrm>
-            <a:off x="1005840" y="3108960"/>
-            <a:ext cx="10058400" cy="365760"/>
-          </a:xfrm>
-          <a:prstGeom prst="rect">
-            <a:avLst/>
-          </a:prstGeom>
-          <a:noFill/>
-        </p:spPr>
-        <p:txBody>
-          <a:bodyPr wrap="square">
-            <a:spAutoFit/>
-          </a:bodyPr>
-          <a:lstStyle/>
-          <a:p>
-            <a:pPr algn="ctr">
-              <a:defRPr sz="1700" b="0">
-                <a:solidFill>
-                  <a:srgbClr val="00D4AA"/>
-                </a:solidFill>
-                <a:latin typeface="Calibri"/>
-              </a:defRPr>
-            </a:pPr>
-            <a:r>
-              <a:t>Detect physiological destabilization from a wrist — intervene on sleep before patients drop out.</a:t>
-            </a:r>
-          </a:p>
-        </p:txBody>
-      </p:sp>
-      <p:sp>
-        <p:nvSpPr>
-          <p:cNvPr id="20" name="TextBox 19"/>
-          <p:cNvSpPr txBox="1"/>
-          <p:nvPr/>
-        </p:nvSpPr>
-        <p:spPr>
-          <a:xfrm>
-            <a:off x="1005840" y="3566160"/>
-            <a:ext cx="10058400" cy="274320"/>
-          </a:xfrm>
-          <a:prstGeom prst="rect">
-            <a:avLst/>
-          </a:prstGeom>
-          <a:noFill/>
-        </p:spPr>
-        <p:txBody>
-          <a:bodyPr wrap="square">
-            <a:spAutoFit/>
-          </a:bodyPr>
-          <a:lstStyle/>
-          <a:p>
-            <a:pPr algn="ctr">
-              <a:defRPr sz="1200" b="0">
-                <a:solidFill>
-                  <a:srgbClr val="888888"/>
-                </a:solidFill>
-                <a:latin typeface="Calibri"/>
-              </a:defRPr>
-            </a:pPr>
-            <a:r>
-              <a:t>FAIR-compliant outputs • Confounder-controlled • Full provenance trail for every discovery</a:t>
+              <a:t>frozen, validated, regulatable. New discoveries trigger a new submission, not a moving target.</a:t>
             </a:r>
           </a:p>
         </p:txBody>
@@ -4917,6 +4682,1218 @@
         </p:nvSpPr>
         <p:spPr>
           <a:xfrm>
+            <a:off x="457200" y="274320"/>
+            <a:ext cx="10972800" cy="640080"/>
+          </a:xfrm>
+          <a:prstGeom prst="rect">
+            <a:avLst/>
+          </a:prstGeom>
+          <a:noFill/>
+        </p:spPr>
+        <p:txBody>
+          <a:bodyPr wrap="square">
+            <a:spAutoFit/>
+          </a:bodyPr>
+          <a:lstStyle/>
+          <a:p>
+            <a:pPr algn="l">
+              <a:defRPr sz="3600" b="1">
+                <a:solidFill>
+                  <a:srgbClr val="00D4AA"/>
+                </a:solidFill>
+                <a:latin typeface="Calibri"/>
+              </a:defRPr>
+            </a:pPr>
+            <a:r>
+              <a:t>Confounder-Aware Discovery</a:t>
+            </a:r>
+          </a:p>
+        </p:txBody>
+      </p:sp>
+      <p:sp>
+        <p:nvSpPr>
+          <p:cNvPr id="3" name="Rounded Rectangle 2"/>
+          <p:cNvSpPr/>
+          <p:nvPr/>
+        </p:nvSpPr>
+        <p:spPr>
+          <a:xfrm>
+            <a:off x="731520" y="1005840"/>
+            <a:ext cx="10515600" cy="640080"/>
+          </a:xfrm>
+          <a:prstGeom prst="roundRect">
+            <a:avLst/>
+          </a:prstGeom>
+          <a:solidFill>
+            <a:srgbClr val="16162A"/>
+          </a:solidFill>
+          <a:ln w="12700">
+            <a:solidFill>
+              <a:srgbClr val="333344"/>
+            </a:solidFill>
+          </a:ln>
+        </p:spPr>
+        <p:style>
+          <a:lnRef idx="1">
+            <a:schemeClr val="accent1"/>
+          </a:lnRef>
+          <a:fillRef idx="3">
+            <a:schemeClr val="accent1"/>
+          </a:fillRef>
+          <a:effectRef idx="2">
+            <a:schemeClr val="accent1"/>
+          </a:effectRef>
+          <a:fontRef idx="minor">
+            <a:schemeClr val="lt1"/>
+          </a:fontRef>
+        </p:style>
+        <p:txBody>
+          <a:bodyPr rtlCol="0" anchor="ctr"/>
+          <a:lstStyle/>
+          <a:p>
+            <a:pPr algn="ctr"/>
+          </a:p>
+        </p:txBody>
+      </p:sp>
+      <p:sp>
+        <p:nvSpPr>
+          <p:cNvPr id="4" name="TextBox 3"/>
+          <p:cNvSpPr txBox="1"/>
+          <p:nvPr/>
+        </p:nvSpPr>
+        <p:spPr>
+          <a:xfrm>
+            <a:off x="1005840" y="1097280"/>
+            <a:ext cx="10058400" cy="457200"/>
+          </a:xfrm>
+          <a:prstGeom prst="rect">
+            <a:avLst/>
+          </a:prstGeom>
+          <a:noFill/>
+        </p:spPr>
+        <p:txBody>
+          <a:bodyPr wrap="square">
+            <a:spAutoFit/>
+          </a:bodyPr>
+          <a:lstStyle/>
+          <a:p>
+            <a:pPr algn="l">
+              <a:defRPr sz="1700" b="0">
+                <a:solidFill>
+                  <a:srgbClr val="FF6B6B"/>
+                </a:solidFill>
+                <a:latin typeface="Calibri"/>
+              </a:defRPr>
+            </a:pPr>
+            <a:r>
+              <a:t>A "depression signal" in HRV might actually be caffeine, alcohol, or exercise.</a:t>
+            </a:r>
+          </a:p>
+        </p:txBody>
+      </p:sp>
+      <p:sp>
+        <p:nvSpPr>
+          <p:cNvPr id="5" name="Rounded Rectangle 4"/>
+          <p:cNvSpPr/>
+          <p:nvPr/>
+        </p:nvSpPr>
+        <p:spPr>
+          <a:xfrm>
+            <a:off x="731520" y="2011680"/>
+            <a:ext cx="4846320" cy="2286000"/>
+          </a:xfrm>
+          <a:prstGeom prst="roundRect">
+            <a:avLst/>
+          </a:prstGeom>
+          <a:solidFill>
+            <a:srgbClr val="16162A"/>
+          </a:solidFill>
+          <a:ln w="12700">
+            <a:solidFill>
+              <a:srgbClr val="333344"/>
+            </a:solidFill>
+          </a:ln>
+        </p:spPr>
+        <p:style>
+          <a:lnRef idx="1">
+            <a:schemeClr val="accent1"/>
+          </a:lnRef>
+          <a:fillRef idx="3">
+            <a:schemeClr val="accent1"/>
+          </a:fillRef>
+          <a:effectRef idx="2">
+            <a:schemeClr val="accent1"/>
+          </a:effectRef>
+          <a:fontRef idx="minor">
+            <a:schemeClr val="lt1"/>
+          </a:fontRef>
+        </p:style>
+        <p:txBody>
+          <a:bodyPr rtlCol="0" anchor="ctr"/>
+          <a:lstStyle/>
+          <a:p>
+            <a:pPr algn="ctr"/>
+          </a:p>
+        </p:txBody>
+      </p:sp>
+      <p:sp>
+        <p:nvSpPr>
+          <p:cNvPr id="6" name="TextBox 5"/>
+          <p:cNvSpPr txBox="1"/>
+          <p:nvPr/>
+        </p:nvSpPr>
+        <p:spPr>
+          <a:xfrm>
+            <a:off x="1005840" y="2103120"/>
+            <a:ext cx="4389120" cy="274320"/>
+          </a:xfrm>
+          <a:prstGeom prst="rect">
+            <a:avLst/>
+          </a:prstGeom>
+          <a:noFill/>
+        </p:spPr>
+        <p:txBody>
+          <a:bodyPr wrap="square">
+            <a:spAutoFit/>
+          </a:bodyPr>
+          <a:lstStyle/>
+          <a:p>
+            <a:pPr algn="l">
+              <a:defRPr sz="1600" b="1">
+                <a:solidFill>
+                  <a:srgbClr val="6C5CE7"/>
+                </a:solidFill>
+                <a:latin typeface="Calibri"/>
+              </a:defRPr>
+            </a:pPr>
+            <a:r>
+              <a:t>Confounders in dataset</a:t>
+            </a:r>
+          </a:p>
+        </p:txBody>
+      </p:sp>
+      <p:sp>
+        <p:nvSpPr>
+          <p:cNvPr id="7" name="TextBox 6"/>
+          <p:cNvSpPr txBox="1"/>
+          <p:nvPr/>
+        </p:nvSpPr>
+        <p:spPr>
+          <a:xfrm>
+            <a:off x="1005840" y="2468880"/>
+            <a:ext cx="4389120" cy="1463040"/>
+          </a:xfrm>
+          <a:prstGeom prst="rect">
+            <a:avLst/>
+          </a:prstGeom>
+          <a:noFill/>
+        </p:spPr>
+        <p:txBody>
+          <a:bodyPr wrap="square">
+            <a:spAutoFit/>
+          </a:bodyPr>
+          <a:lstStyle/>
+          <a:p>
+            <a:pPr algn="l">
+              <a:defRPr sz="1400" b="0">
+                <a:solidFill>
+                  <a:srgbClr val="E0E0E0"/>
+                </a:solidFill>
+                <a:latin typeface="Calibri"/>
+              </a:defRPr>
+            </a:pPr>
+            <a:r>
+              <a:t>Coffee intake        1–5 scale</a:t>
+            </a:r>
+            <a:br/>
+            <a:r>
+              <a:t>Alcohol use           1–4 scale</a:t>
+            </a:r>
+            <a:br/>
+            <a:r>
+              <a:t>Smoking               1–5 scale</a:t>
+            </a:r>
+            <a:br/>
+            <a:r>
+              <a:t>Exercise frequency    1–5 scale</a:t>
+            </a:r>
+          </a:p>
+        </p:txBody>
+      </p:sp>
+      <p:sp>
+        <p:nvSpPr>
+          <p:cNvPr id="8" name="Rounded Rectangle 7"/>
+          <p:cNvSpPr/>
+          <p:nvPr/>
+        </p:nvSpPr>
+        <p:spPr>
+          <a:xfrm>
+            <a:off x="5943600" y="2011680"/>
+            <a:ext cx="4846320" cy="2286000"/>
+          </a:xfrm>
+          <a:prstGeom prst="roundRect">
+            <a:avLst/>
+          </a:prstGeom>
+          <a:solidFill>
+            <a:srgbClr val="0D201C"/>
+          </a:solidFill>
+          <a:ln w="12700">
+            <a:solidFill>
+              <a:srgbClr val="333344"/>
+            </a:solidFill>
+          </a:ln>
+        </p:spPr>
+        <p:style>
+          <a:lnRef idx="1">
+            <a:schemeClr val="accent1"/>
+          </a:lnRef>
+          <a:fillRef idx="3">
+            <a:schemeClr val="accent1"/>
+          </a:fillRef>
+          <a:effectRef idx="2">
+            <a:schemeClr val="accent1"/>
+          </a:effectRef>
+          <a:fontRef idx="minor">
+            <a:schemeClr val="lt1"/>
+          </a:fontRef>
+        </p:style>
+        <p:txBody>
+          <a:bodyPr rtlCol="0" anchor="ctr"/>
+          <a:lstStyle/>
+          <a:p>
+            <a:pPr algn="ctr"/>
+          </a:p>
+        </p:txBody>
+      </p:sp>
+      <p:sp>
+        <p:nvSpPr>
+          <p:cNvPr id="9" name="TextBox 8"/>
+          <p:cNvSpPr txBox="1"/>
+          <p:nvPr/>
+        </p:nvSpPr>
+        <p:spPr>
+          <a:xfrm>
+            <a:off x="6217920" y="2103120"/>
+            <a:ext cx="4389120" cy="274320"/>
+          </a:xfrm>
+          <a:prstGeom prst="rect">
+            <a:avLst/>
+          </a:prstGeom>
+          <a:noFill/>
+        </p:spPr>
+        <p:txBody>
+          <a:bodyPr wrap="square">
+            <a:spAutoFit/>
+          </a:bodyPr>
+          <a:lstStyle/>
+          <a:p>
+            <a:pPr algn="l">
+              <a:defRPr sz="1600" b="1">
+                <a:solidFill>
+                  <a:srgbClr val="00D4AA"/>
+                </a:solidFill>
+                <a:latin typeface="Calibri"/>
+              </a:defRPr>
+            </a:pPr>
+            <a:r>
+              <a:t>Our approach</a:t>
+            </a:r>
+          </a:p>
+        </p:txBody>
+      </p:sp>
+      <p:sp>
+        <p:nvSpPr>
+          <p:cNvPr id="10" name="TextBox 9"/>
+          <p:cNvSpPr txBox="1"/>
+          <p:nvPr/>
+        </p:nvSpPr>
+        <p:spPr>
+          <a:xfrm>
+            <a:off x="6217920" y="2468880"/>
+            <a:ext cx="4389120" cy="1463040"/>
+          </a:xfrm>
+          <a:prstGeom prst="rect">
+            <a:avLst/>
+          </a:prstGeom>
+          <a:noFill/>
+        </p:spPr>
+        <p:txBody>
+          <a:bodyPr wrap="square">
+            <a:spAutoFit/>
+          </a:bodyPr>
+          <a:lstStyle/>
+          <a:p>
+            <a:pPr algn="l">
+              <a:defRPr sz="1300" b="0">
+                <a:solidFill>
+                  <a:srgbClr val="E0E0E0"/>
+                </a:solidFill>
+                <a:latin typeface="Calibri"/>
+              </a:defRPr>
+            </a:pPr>
+            <a:r>
+              <a:t>• Residualize features against confounders</a:t>
+            </a:r>
+            <a:br/>
+            <a:r>
+              <a:t>• Report both raw and adjusted effect sizes</a:t>
+            </a:r>
+            <a:br/>
+            <a:r>
+              <a:t>• Flag features where d drops &gt;30% after adjustment</a:t>
+            </a:r>
+            <a:br/>
+            <a:r>
+              <a:t>• FAIR-compliant output: full provenance for each finding</a:t>
+            </a:r>
+          </a:p>
+        </p:txBody>
+      </p:sp>
+      <p:sp>
+        <p:nvSpPr>
+          <p:cNvPr id="11" name="TextBox 10"/>
+          <p:cNvSpPr txBox="1"/>
+          <p:nvPr/>
+        </p:nvSpPr>
+        <p:spPr>
+          <a:xfrm>
+            <a:off x="731520" y="4572000"/>
+            <a:ext cx="10515600" cy="365760"/>
+          </a:xfrm>
+          <a:prstGeom prst="rect">
+            <a:avLst/>
+          </a:prstGeom>
+          <a:noFill/>
+        </p:spPr>
+        <p:txBody>
+          <a:bodyPr wrap="square">
+            <a:spAutoFit/>
+          </a:bodyPr>
+          <a:lstStyle/>
+          <a:p>
+            <a:pPr algn="ctr">
+              <a:defRPr sz="1100" b="0">
+                <a:solidFill>
+                  <a:srgbClr val="888888"/>
+                </a:solidFill>
+                <a:latin typeface="Calibri"/>
+              </a:defRPr>
+            </a:pPr>
+            <a:r>
+              <a:t>Every discovery includes: raw effect, adjusted effect, confounders controlled, CI, permutation p-value, FDR status</a:t>
+            </a:r>
+          </a:p>
+        </p:txBody>
+      </p:sp>
+    </p:spTree>
+  </p:cSld>
+  <p:clrMapOvr>
+    <a:masterClrMapping/>
+  </p:clrMapOvr>
+</p:sld>
+</file>
+
+<file path=ppt/slides/slide14.xml><?xml version="1.0" encoding="utf-8"?>
+<p:sld xmlns:a="http://schemas.openxmlformats.org/drawingml/2006/main" xmlns:p="http://schemas.openxmlformats.org/presentationml/2006/main" xmlns:r="http://schemas.openxmlformats.org/officeDocument/2006/relationships">
+  <p:cSld>
+    <p:bg>
+      <p:bgPr>
+        <a:solidFill>
+          <a:srgbClr val="0A0A1A"/>
+        </a:solidFill>
+        <a:effectLst/>
+      </p:bgPr>
+    </p:bg>
+    <p:spTree>
+      <p:nvGrpSpPr>
+        <p:cNvPr id="1" name=""/>
+        <p:cNvGrpSpPr/>
+        <p:nvPr/>
+      </p:nvGrpSpPr>
+      <p:grpSpPr/>
+      <p:sp>
+        <p:nvSpPr>
+          <p:cNvPr id="2" name="TextBox 1"/>
+          <p:cNvSpPr txBox="1"/>
+          <p:nvPr/>
+        </p:nvSpPr>
+        <p:spPr>
+          <a:xfrm>
+            <a:off x="457200" y="274320"/>
+            <a:ext cx="10972800" cy="640080"/>
+          </a:xfrm>
+          <a:prstGeom prst="rect">
+            <a:avLst/>
+          </a:prstGeom>
+          <a:noFill/>
+        </p:spPr>
+        <p:txBody>
+          <a:bodyPr wrap="square">
+            <a:spAutoFit/>
+          </a:bodyPr>
+          <a:lstStyle/>
+          <a:p>
+            <a:pPr algn="l">
+              <a:defRPr sz="3600" b="1">
+                <a:solidFill>
+                  <a:srgbClr val="00D4AA"/>
+                </a:solidFill>
+                <a:latin typeface="Calibri"/>
+              </a:defRPr>
+            </a:pPr>
+            <a:r>
+              <a:t>What's Next</a:t>
+            </a:r>
+          </a:p>
+        </p:txBody>
+      </p:sp>
+      <p:sp>
+        <p:nvSpPr>
+          <p:cNvPr id="3" name="Rounded Rectangle 2"/>
+          <p:cNvSpPr/>
+          <p:nvPr/>
+        </p:nvSpPr>
+        <p:spPr>
+          <a:xfrm>
+            <a:off x="731520" y="1188720"/>
+            <a:ext cx="2286000" cy="1371600"/>
+          </a:xfrm>
+          <a:prstGeom prst="roundRect">
+            <a:avLst/>
+          </a:prstGeom>
+          <a:solidFill>
+            <a:srgbClr val="0D201C"/>
+          </a:solidFill>
+          <a:ln w="12700">
+            <a:solidFill>
+              <a:srgbClr val="333344"/>
+            </a:solidFill>
+          </a:ln>
+        </p:spPr>
+        <p:style>
+          <a:lnRef idx="1">
+            <a:schemeClr val="accent1"/>
+          </a:lnRef>
+          <a:fillRef idx="3">
+            <a:schemeClr val="accent1"/>
+          </a:fillRef>
+          <a:effectRef idx="2">
+            <a:schemeClr val="accent1"/>
+          </a:effectRef>
+          <a:fontRef idx="minor">
+            <a:schemeClr val="lt1"/>
+          </a:fontRef>
+        </p:style>
+        <p:txBody>
+          <a:bodyPr rtlCol="0" anchor="ctr"/>
+          <a:lstStyle/>
+          <a:p>
+            <a:pPr algn="ctr"/>
+          </a:p>
+        </p:txBody>
+      </p:sp>
+      <p:sp>
+        <p:nvSpPr>
+          <p:cNvPr id="4" name="TextBox 3"/>
+          <p:cNvSpPr txBox="1"/>
+          <p:nvPr/>
+        </p:nvSpPr>
+        <p:spPr>
+          <a:xfrm>
+            <a:off x="822960" y="1234440"/>
+            <a:ext cx="2103120" cy="457200"/>
+          </a:xfrm>
+          <a:prstGeom prst="rect">
+            <a:avLst/>
+          </a:prstGeom>
+          <a:noFill/>
+        </p:spPr>
+        <p:txBody>
+          <a:bodyPr wrap="square">
+            <a:spAutoFit/>
+          </a:bodyPr>
+          <a:lstStyle/>
+          <a:p>
+            <a:pPr algn="ctr">
+              <a:defRPr sz="1500" b="1">
+                <a:solidFill>
+                  <a:srgbClr val="FFFFFF"/>
+                </a:solidFill>
+                <a:latin typeface="Calibri"/>
+              </a:defRPr>
+            </a:pPr>
+            <a:r>
+              <a:t>Hackathon</a:t>
+            </a:r>
+          </a:p>
+        </p:txBody>
+      </p:sp>
+      <p:sp>
+        <p:nvSpPr>
+          <p:cNvPr id="5" name="TextBox 4"/>
+          <p:cNvSpPr txBox="1"/>
+          <p:nvPr/>
+        </p:nvSpPr>
+        <p:spPr>
+          <a:xfrm>
+            <a:off x="822960" y="1737360"/>
+            <a:ext cx="2103120" cy="640080"/>
+          </a:xfrm>
+          <a:prstGeom prst="rect">
+            <a:avLst/>
+          </a:prstGeom>
+          <a:noFill/>
+        </p:spPr>
+        <p:txBody>
+          <a:bodyPr wrap="square">
+            <a:spAutoFit/>
+          </a:bodyPr>
+          <a:lstStyle/>
+          <a:p>
+            <a:pPr algn="ctr">
+              <a:defRPr sz="1100" b="0">
+                <a:solidFill>
+                  <a:srgbClr val="888888"/>
+                </a:solidFill>
+                <a:latin typeface="Calibri"/>
+              </a:defRPr>
+            </a:pPr>
+            <a:r>
+              <a:t>Discovery +</a:t>
+            </a:r>
+            <a:br/>
+            <a:r>
+              <a:t>validation</a:t>
+            </a:r>
+          </a:p>
+        </p:txBody>
+      </p:sp>
+      <p:sp>
+        <p:nvSpPr>
+          <p:cNvPr id="6" name="TextBox 5"/>
+          <p:cNvSpPr txBox="1"/>
+          <p:nvPr/>
+        </p:nvSpPr>
+        <p:spPr>
+          <a:xfrm>
+            <a:off x="3017520" y="1554480"/>
+            <a:ext cx="548640" cy="457200"/>
+          </a:xfrm>
+          <a:prstGeom prst="rect">
+            <a:avLst/>
+          </a:prstGeom>
+          <a:noFill/>
+        </p:spPr>
+        <p:txBody>
+          <a:bodyPr wrap="square">
+            <a:spAutoFit/>
+          </a:bodyPr>
+          <a:lstStyle/>
+          <a:p>
+            <a:pPr algn="ctr">
+              <a:defRPr sz="2800" b="0">
+                <a:solidFill>
+                  <a:srgbClr val="00D4AA"/>
+                </a:solidFill>
+                <a:latin typeface="Calibri"/>
+              </a:defRPr>
+            </a:pPr>
+            <a:r>
+              <a:t>→</a:t>
+            </a:r>
+          </a:p>
+        </p:txBody>
+      </p:sp>
+      <p:sp>
+        <p:nvSpPr>
+          <p:cNvPr id="7" name="Rounded Rectangle 6"/>
+          <p:cNvSpPr/>
+          <p:nvPr/>
+        </p:nvSpPr>
+        <p:spPr>
+          <a:xfrm>
+            <a:off x="3566160" y="1188720"/>
+            <a:ext cx="2286000" cy="1371600"/>
+          </a:xfrm>
+          <a:prstGeom prst="roundRect">
+            <a:avLst/>
+          </a:prstGeom>
+          <a:solidFill>
+            <a:srgbClr val="1A1530"/>
+          </a:solidFill>
+          <a:ln w="12700">
+            <a:solidFill>
+              <a:srgbClr val="333344"/>
+            </a:solidFill>
+          </a:ln>
+        </p:spPr>
+        <p:style>
+          <a:lnRef idx="1">
+            <a:schemeClr val="accent1"/>
+          </a:lnRef>
+          <a:fillRef idx="3">
+            <a:schemeClr val="accent1"/>
+          </a:fillRef>
+          <a:effectRef idx="2">
+            <a:schemeClr val="accent1"/>
+          </a:effectRef>
+          <a:fontRef idx="minor">
+            <a:schemeClr val="lt1"/>
+          </a:fontRef>
+        </p:style>
+        <p:txBody>
+          <a:bodyPr rtlCol="0" anchor="ctr"/>
+          <a:lstStyle/>
+          <a:p>
+            <a:pPr algn="ctr"/>
+          </a:p>
+        </p:txBody>
+      </p:sp>
+      <p:sp>
+        <p:nvSpPr>
+          <p:cNvPr id="8" name="TextBox 7"/>
+          <p:cNvSpPr txBox="1"/>
+          <p:nvPr/>
+        </p:nvSpPr>
+        <p:spPr>
+          <a:xfrm>
+            <a:off x="3657600" y="1234440"/>
+            <a:ext cx="2103120" cy="457200"/>
+          </a:xfrm>
+          <a:prstGeom prst="rect">
+            <a:avLst/>
+          </a:prstGeom>
+          <a:noFill/>
+        </p:spPr>
+        <p:txBody>
+          <a:bodyPr wrap="square">
+            <a:spAutoFit/>
+          </a:bodyPr>
+          <a:lstStyle/>
+          <a:p>
+            <a:pPr algn="ctr">
+              <a:defRPr sz="1500" b="1">
+                <a:solidFill>
+                  <a:srgbClr val="FFFFFF"/>
+                </a:solidFill>
+                <a:latin typeface="Calibri"/>
+              </a:defRPr>
+            </a:pPr>
+            <a:r>
+              <a:t>Clinical</a:t>
+            </a:r>
+            <a:br/>
+            <a:r>
+              <a:t>Validation</a:t>
+            </a:r>
+          </a:p>
+        </p:txBody>
+      </p:sp>
+      <p:sp>
+        <p:nvSpPr>
+          <p:cNvPr id="9" name="TextBox 8"/>
+          <p:cNvSpPr txBox="1"/>
+          <p:nvPr/>
+        </p:nvSpPr>
+        <p:spPr>
+          <a:xfrm>
+            <a:off x="3657600" y="1737360"/>
+            <a:ext cx="2103120" cy="640080"/>
+          </a:xfrm>
+          <a:prstGeom prst="rect">
+            <a:avLst/>
+          </a:prstGeom>
+          <a:noFill/>
+        </p:spPr>
+        <p:txBody>
+          <a:bodyPr wrap="square">
+            <a:spAutoFit/>
+          </a:bodyPr>
+          <a:lstStyle/>
+          <a:p>
+            <a:pPr algn="ctr">
+              <a:defRPr sz="1100" b="0">
+                <a:solidFill>
+                  <a:srgbClr val="888888"/>
+                </a:solidFill>
+                <a:latin typeface="Calibri"/>
+              </a:defRPr>
+            </a:pPr>
+            <a:r>
+              <a:t>Prospective study</a:t>
+            </a:r>
+            <a:br/>
+            <a:r>
+              <a:t>with Uni of Hamburg</a:t>
+            </a:r>
+          </a:p>
+        </p:txBody>
+      </p:sp>
+      <p:sp>
+        <p:nvSpPr>
+          <p:cNvPr id="10" name="TextBox 9"/>
+          <p:cNvSpPr txBox="1"/>
+          <p:nvPr/>
+        </p:nvSpPr>
+        <p:spPr>
+          <a:xfrm>
+            <a:off x="5852160" y="1554480"/>
+            <a:ext cx="548640" cy="457200"/>
+          </a:xfrm>
+          <a:prstGeom prst="rect">
+            <a:avLst/>
+          </a:prstGeom>
+          <a:noFill/>
+        </p:spPr>
+        <p:txBody>
+          <a:bodyPr wrap="square">
+            <a:spAutoFit/>
+          </a:bodyPr>
+          <a:lstStyle/>
+          <a:p>
+            <a:pPr algn="ctr">
+              <a:defRPr sz="2800" b="0">
+                <a:solidFill>
+                  <a:srgbClr val="00D4AA"/>
+                </a:solidFill>
+                <a:latin typeface="Calibri"/>
+              </a:defRPr>
+            </a:pPr>
+            <a:r>
+              <a:t>→</a:t>
+            </a:r>
+          </a:p>
+        </p:txBody>
+      </p:sp>
+      <p:sp>
+        <p:nvSpPr>
+          <p:cNvPr id="11" name="Rounded Rectangle 10"/>
+          <p:cNvSpPr/>
+          <p:nvPr/>
+        </p:nvSpPr>
+        <p:spPr>
+          <a:xfrm>
+            <a:off x="6400800" y="1188720"/>
+            <a:ext cx="2286000" cy="1371600"/>
+          </a:xfrm>
+          <a:prstGeom prst="roundRect">
+            <a:avLst/>
+          </a:prstGeom>
+          <a:solidFill>
+            <a:srgbClr val="1A1530"/>
+          </a:solidFill>
+          <a:ln w="12700">
+            <a:solidFill>
+              <a:srgbClr val="333344"/>
+            </a:solidFill>
+          </a:ln>
+        </p:spPr>
+        <p:style>
+          <a:lnRef idx="1">
+            <a:schemeClr val="accent1"/>
+          </a:lnRef>
+          <a:fillRef idx="3">
+            <a:schemeClr val="accent1"/>
+          </a:fillRef>
+          <a:effectRef idx="2">
+            <a:schemeClr val="accent1"/>
+          </a:effectRef>
+          <a:fontRef idx="minor">
+            <a:schemeClr val="lt1"/>
+          </a:fontRef>
+        </p:style>
+        <p:txBody>
+          <a:bodyPr rtlCol="0" anchor="ctr"/>
+          <a:lstStyle/>
+          <a:p>
+            <a:pPr algn="ctr"/>
+          </a:p>
+        </p:txBody>
+      </p:sp>
+      <p:sp>
+        <p:nvSpPr>
+          <p:cNvPr id="12" name="TextBox 11"/>
+          <p:cNvSpPr txBox="1"/>
+          <p:nvPr/>
+        </p:nvSpPr>
+        <p:spPr>
+          <a:xfrm>
+            <a:off x="6492240" y="1234440"/>
+            <a:ext cx="2103120" cy="457200"/>
+          </a:xfrm>
+          <a:prstGeom prst="rect">
+            <a:avLst/>
+          </a:prstGeom>
+          <a:noFill/>
+        </p:spPr>
+        <p:txBody>
+          <a:bodyPr wrap="square">
+            <a:spAutoFit/>
+          </a:bodyPr>
+          <a:lstStyle/>
+          <a:p>
+            <a:pPr algn="ctr">
+              <a:defRPr sz="1500" b="1">
+                <a:solidFill>
+                  <a:srgbClr val="FFFFFF"/>
+                </a:solidFill>
+                <a:latin typeface="Calibri"/>
+              </a:defRPr>
+            </a:pPr>
+            <a:r>
+              <a:t>Pharma Pilot</a:t>
+            </a:r>
+          </a:p>
+        </p:txBody>
+      </p:sp>
+      <p:sp>
+        <p:nvSpPr>
+          <p:cNvPr id="13" name="TextBox 12"/>
+          <p:cNvSpPr txBox="1"/>
+          <p:nvPr/>
+        </p:nvSpPr>
+        <p:spPr>
+          <a:xfrm>
+            <a:off x="6492240" y="1737360"/>
+            <a:ext cx="2103120" cy="640080"/>
+          </a:xfrm>
+          <a:prstGeom prst="rect">
+            <a:avLst/>
+          </a:prstGeom>
+          <a:noFill/>
+        </p:spPr>
+        <p:txBody>
+          <a:bodyPr wrap="square">
+            <a:spAutoFit/>
+          </a:bodyPr>
+          <a:lstStyle/>
+          <a:p>
+            <a:pPr algn="ctr">
+              <a:defRPr sz="1100" b="0">
+                <a:solidFill>
+                  <a:srgbClr val="888888"/>
+                </a:solidFill>
+                <a:latin typeface="Calibri"/>
+              </a:defRPr>
+            </a:pPr>
+            <a:r>
+              <a:t>Discovery engine for</a:t>
+            </a:r>
+            <a:br/>
+            <a:r>
+              <a:t>digital endpoints</a:t>
+            </a:r>
+          </a:p>
+        </p:txBody>
+      </p:sp>
+      <p:sp>
+        <p:nvSpPr>
+          <p:cNvPr id="14" name="TextBox 13"/>
+          <p:cNvSpPr txBox="1"/>
+          <p:nvPr/>
+        </p:nvSpPr>
+        <p:spPr>
+          <a:xfrm>
+            <a:off x="8686800" y="1554480"/>
+            <a:ext cx="548640" cy="457200"/>
+          </a:xfrm>
+          <a:prstGeom prst="rect">
+            <a:avLst/>
+          </a:prstGeom>
+          <a:noFill/>
+        </p:spPr>
+        <p:txBody>
+          <a:bodyPr wrap="square">
+            <a:spAutoFit/>
+          </a:bodyPr>
+          <a:lstStyle/>
+          <a:p>
+            <a:pPr algn="ctr">
+              <a:defRPr sz="2800" b="0">
+                <a:solidFill>
+                  <a:srgbClr val="00D4AA"/>
+                </a:solidFill>
+                <a:latin typeface="Calibri"/>
+              </a:defRPr>
+            </a:pPr>
+            <a:r>
+              <a:t>→</a:t>
+            </a:r>
+          </a:p>
+        </p:txBody>
+      </p:sp>
+      <p:sp>
+        <p:nvSpPr>
+          <p:cNvPr id="15" name="Rounded Rectangle 14"/>
+          <p:cNvSpPr/>
+          <p:nvPr/>
+        </p:nvSpPr>
+        <p:spPr>
+          <a:xfrm>
+            <a:off x="9235440" y="1188720"/>
+            <a:ext cx="2286000" cy="1371600"/>
+          </a:xfrm>
+          <a:prstGeom prst="roundRect">
+            <a:avLst/>
+          </a:prstGeom>
+          <a:solidFill>
+            <a:srgbClr val="1A1530"/>
+          </a:solidFill>
+          <a:ln w="12700">
+            <a:solidFill>
+              <a:srgbClr val="333344"/>
+            </a:solidFill>
+          </a:ln>
+        </p:spPr>
+        <p:style>
+          <a:lnRef idx="1">
+            <a:schemeClr val="accent1"/>
+          </a:lnRef>
+          <a:fillRef idx="3">
+            <a:schemeClr val="accent1"/>
+          </a:fillRef>
+          <a:effectRef idx="2">
+            <a:schemeClr val="accent1"/>
+          </a:effectRef>
+          <a:fontRef idx="minor">
+            <a:schemeClr val="lt1"/>
+          </a:fontRef>
+        </p:style>
+        <p:txBody>
+          <a:bodyPr rtlCol="0" anchor="ctr"/>
+          <a:lstStyle/>
+          <a:p>
+            <a:pPr algn="ctr"/>
+          </a:p>
+        </p:txBody>
+      </p:sp>
+      <p:sp>
+        <p:nvSpPr>
+          <p:cNvPr id="16" name="TextBox 15"/>
+          <p:cNvSpPr txBox="1"/>
+          <p:nvPr/>
+        </p:nvSpPr>
+        <p:spPr>
+          <a:xfrm>
+            <a:off x="9326880" y="1234440"/>
+            <a:ext cx="2103120" cy="457200"/>
+          </a:xfrm>
+          <a:prstGeom prst="rect">
+            <a:avLst/>
+          </a:prstGeom>
+          <a:noFill/>
+        </p:spPr>
+        <p:txBody>
+          <a:bodyPr wrap="square">
+            <a:spAutoFit/>
+          </a:bodyPr>
+          <a:lstStyle/>
+          <a:p>
+            <a:pPr algn="ctr">
+              <a:defRPr sz="1500" b="1">
+                <a:solidFill>
+                  <a:srgbClr val="FFFFFF"/>
+                </a:solidFill>
+                <a:latin typeface="Calibri"/>
+              </a:defRPr>
+            </a:pPr>
+            <a:r>
+              <a:t>SaMD Filing</a:t>
+            </a:r>
+          </a:p>
+        </p:txBody>
+      </p:sp>
+      <p:sp>
+        <p:nvSpPr>
+          <p:cNvPr id="17" name="TextBox 16"/>
+          <p:cNvSpPr txBox="1"/>
+          <p:nvPr/>
+        </p:nvSpPr>
+        <p:spPr>
+          <a:xfrm>
+            <a:off x="9326880" y="1737360"/>
+            <a:ext cx="2103120" cy="640080"/>
+          </a:xfrm>
+          <a:prstGeom prst="rect">
+            <a:avLst/>
+          </a:prstGeom>
+          <a:noFill/>
+        </p:spPr>
+        <p:txBody>
+          <a:bodyPr wrap="square">
+            <a:spAutoFit/>
+          </a:bodyPr>
+          <a:lstStyle/>
+          <a:p>
+            <a:pPr algn="ctr">
+              <a:defRPr sz="1100" b="0">
+                <a:solidFill>
+                  <a:srgbClr val="888888"/>
+                </a:solidFill>
+                <a:latin typeface="Calibri"/>
+              </a:defRPr>
+            </a:pPr>
+            <a:r>
+              <a:t>Frozen model →</a:t>
+            </a:r>
+            <a:br/>
+            <a:r>
+              <a:t>Health Canada Class II</a:t>
+            </a:r>
+          </a:p>
+        </p:txBody>
+      </p:sp>
+      <p:sp>
+        <p:nvSpPr>
+          <p:cNvPr id="18" name="Rounded Rectangle 17"/>
+          <p:cNvSpPr/>
+          <p:nvPr/>
+        </p:nvSpPr>
+        <p:spPr>
+          <a:xfrm>
+            <a:off x="731520" y="3017520"/>
+            <a:ext cx="10515600" cy="914400"/>
+          </a:xfrm>
+          <a:prstGeom prst="roundRect">
+            <a:avLst/>
+          </a:prstGeom>
+          <a:solidFill>
+            <a:srgbClr val="0D201C"/>
+          </a:solidFill>
+          <a:ln w="12700">
+            <a:solidFill>
+              <a:srgbClr val="333344"/>
+            </a:solidFill>
+          </a:ln>
+        </p:spPr>
+        <p:style>
+          <a:lnRef idx="1">
+            <a:schemeClr val="accent1"/>
+          </a:lnRef>
+          <a:fillRef idx="3">
+            <a:schemeClr val="accent1"/>
+          </a:fillRef>
+          <a:effectRef idx="2">
+            <a:schemeClr val="accent1"/>
+          </a:effectRef>
+          <a:fontRef idx="minor">
+            <a:schemeClr val="lt1"/>
+          </a:fontRef>
+        </p:style>
+        <p:txBody>
+          <a:bodyPr rtlCol="0" anchor="ctr"/>
+          <a:lstStyle/>
+          <a:p>
+            <a:pPr algn="ctr"/>
+          </a:p>
+        </p:txBody>
+      </p:sp>
+      <p:sp>
+        <p:nvSpPr>
+          <p:cNvPr id="19" name="TextBox 18"/>
+          <p:cNvSpPr txBox="1"/>
+          <p:nvPr/>
+        </p:nvSpPr>
+        <p:spPr>
+          <a:xfrm>
+            <a:off x="1005840" y="3108960"/>
+            <a:ext cx="10058400" cy="365760"/>
+          </a:xfrm>
+          <a:prstGeom prst="rect">
+            <a:avLst/>
+          </a:prstGeom>
+          <a:noFill/>
+        </p:spPr>
+        <p:txBody>
+          <a:bodyPr wrap="square">
+            <a:spAutoFit/>
+          </a:bodyPr>
+          <a:lstStyle/>
+          <a:p>
+            <a:pPr algn="ctr">
+              <a:defRPr sz="1700" b="0">
+                <a:solidFill>
+                  <a:srgbClr val="00D4AA"/>
+                </a:solidFill>
+                <a:latin typeface="Calibri"/>
+              </a:defRPr>
+            </a:pPr>
+            <a:r>
+              <a:t>Detect physiological destabilization from a wrist — intervene on sleep before patients drop out.</a:t>
+            </a:r>
+          </a:p>
+        </p:txBody>
+      </p:sp>
+      <p:sp>
+        <p:nvSpPr>
+          <p:cNvPr id="20" name="TextBox 19"/>
+          <p:cNvSpPr txBox="1"/>
+          <p:nvPr/>
+        </p:nvSpPr>
+        <p:spPr>
+          <a:xfrm>
+            <a:off x="1005840" y="3566160"/>
+            <a:ext cx="10058400" cy="274320"/>
+          </a:xfrm>
+          <a:prstGeom prst="rect">
+            <a:avLst/>
+          </a:prstGeom>
+          <a:noFill/>
+        </p:spPr>
+        <p:txBody>
+          <a:bodyPr wrap="square">
+            <a:spAutoFit/>
+          </a:bodyPr>
+          <a:lstStyle/>
+          <a:p>
+            <a:pPr algn="ctr">
+              <a:defRPr sz="1200" b="0">
+                <a:solidFill>
+                  <a:srgbClr val="888888"/>
+                </a:solidFill>
+                <a:latin typeface="Calibri"/>
+              </a:defRPr>
+            </a:pPr>
+            <a:r>
+              <a:t>FAIR-compliant outputs • Confounder-controlled • Full provenance trail for every discovery</a:t>
+            </a:r>
+          </a:p>
+        </p:txBody>
+      </p:sp>
+    </p:spTree>
+  </p:cSld>
+  <p:clrMapOvr>
+    <a:masterClrMapping/>
+  </p:clrMapOvr>
+</p:sld>
+</file>
+
+<file path=ppt/slides/slide15.xml><?xml version="1.0" encoding="utf-8"?>
+<p:sld xmlns:a="http://schemas.openxmlformats.org/drawingml/2006/main" xmlns:p="http://schemas.openxmlformats.org/presentationml/2006/main" xmlns:r="http://schemas.openxmlformats.org/officeDocument/2006/relationships">
+  <p:cSld>
+    <p:bg>
+      <p:bgPr>
+        <a:solidFill>
+          <a:srgbClr val="0A0A1A"/>
+        </a:solidFill>
+        <a:effectLst/>
+      </p:bgPr>
+    </p:bg>
+    <p:spTree>
+      <p:nvGrpSpPr>
+        <p:cNvPr id="1" name=""/>
+        <p:cNvGrpSpPr/>
+        <p:nvPr/>
+      </p:nvGrpSpPr>
+      <p:grpSpPr/>
+      <p:sp>
+        <p:nvSpPr>
+          <p:cNvPr id="2" name="TextBox 1"/>
+          <p:cNvSpPr txBox="1"/>
+          <p:nvPr/>
+        </p:nvSpPr>
+        <p:spPr>
+          <a:xfrm>
             <a:off x="914400" y="1371600"/>
             <a:ext cx="10058400" cy="914400"/>
           </a:xfrm>
@@ -9154,7 +10131,7 @@
           <a:lstStyle/>
           <a:p>
             <a:pPr algn="l">
-              <a:defRPr sz="3600" b="1">
+              <a:defRPr sz="3400" b="1">
                 <a:solidFill>
                   <a:srgbClr val="00D4AA"/>
                 </a:solidFill>
@@ -9162,7 +10139,7 @@
               </a:defRPr>
             </a:pPr>
             <a:r>
-              <a:t>Why This Matters Clinically</a:t>
+              <a:t>Methods: Model &amp; Evaluation</a:t>
             </a:r>
           </a:p>
         </p:txBody>
@@ -9175,14 +10152,14 @@
         </p:nvSpPr>
         <p:spPr>
           <a:xfrm>
-            <a:off x="731520" y="1005840"/>
-            <a:ext cx="10515600" cy="1188720"/>
+            <a:off x="731520" y="1097280"/>
+            <a:ext cx="4846320" cy="2560320"/>
           </a:xfrm>
           <a:prstGeom prst="roundRect">
             <a:avLst/>
           </a:prstGeom>
           <a:solidFill>
-            <a:srgbClr val="1A1530"/>
+            <a:srgbClr val="0D201C"/>
           </a:solidFill>
           <a:ln w="12700">
             <a:solidFill>
@@ -9220,8 +10197,8 @@
         </p:nvSpPr>
         <p:spPr>
           <a:xfrm>
-            <a:off x="1005840" y="1097280"/>
-            <a:ext cx="10058400" cy="731520"/>
+            <a:off x="1005840" y="1188720"/>
+            <a:ext cx="4389120" cy="274320"/>
           </a:xfrm>
           <a:prstGeom prst="rect">
             <a:avLst/>
@@ -9235,7 +10212,43 @@
           <a:lstStyle/>
           <a:p>
             <a:pPr algn="l">
-              <a:defRPr sz="1700" b="0">
+              <a:defRPr sz="1600" b="1">
+                <a:solidFill>
+                  <a:srgbClr val="00D4AA"/>
+                </a:solidFill>
+                <a:latin typeface="Calibri"/>
+              </a:defRPr>
+            </a:pPr>
+            <a:r>
+              <a:t>Data Split</a:t>
+            </a:r>
+          </a:p>
+        </p:txBody>
+      </p:sp>
+      <p:sp>
+        <p:nvSpPr>
+          <p:cNvPr id="5" name="TextBox 4"/>
+          <p:cNvSpPr txBox="1"/>
+          <p:nvPr/>
+        </p:nvSpPr>
+        <p:spPr>
+          <a:xfrm>
+            <a:off x="1005840" y="1554480"/>
+            <a:ext cx="4389120" cy="1828800"/>
+          </a:xfrm>
+          <a:prstGeom prst="rect">
+            <a:avLst/>
+          </a:prstGeom>
+          <a:noFill/>
+        </p:spPr>
+        <p:txBody>
+          <a:bodyPr wrap="square">
+            <a:spAutoFit/>
+          </a:bodyPr>
+          <a:lstStyle/>
+          <a:p>
+            <a:pPr algn="l">
+              <a:defRPr sz="1300" b="0">
                 <a:solidFill>
                   <a:srgbClr val="E0E0E0"/>
                 </a:solidFill>
@@ -9243,47 +10256,25 @@
               </a:defRPr>
             </a:pPr>
             <a:r>
-              <a:t>"The good thing with sleep problems is: if you treat them it hits two birds</a:t>
+              <a:t>49 subjects (Baigutanova et al. 2025)</a:t>
             </a:r>
             <a:br/>
             <a:r>
-              <a:t>with one stone — a bothering problem that also triggers other symptoms."</a:t>
-            </a:r>
-          </a:p>
-        </p:txBody>
-      </p:sp>
-      <p:sp>
-        <p:nvSpPr>
-          <p:cNvPr id="5" name="TextBox 4"/>
-          <p:cNvSpPr txBox="1"/>
-          <p:nvPr/>
-        </p:nvSpPr>
-        <p:spPr>
-          <a:xfrm>
-            <a:off x="1005840" y="1828800"/>
-            <a:ext cx="10058400" cy="274320"/>
-          </a:xfrm>
-          <a:prstGeom prst="rect">
-            <a:avLst/>
-          </a:prstGeom>
-          <a:noFill/>
-        </p:spPr>
-        <p:txBody>
-          <a:bodyPr wrap="square">
-            <a:spAutoFit/>
-          </a:bodyPr>
-          <a:lstStyle/>
-          <a:p>
-            <a:pPr algn="l">
-              <a:defRPr sz="1200" b="0">
-                <a:solidFill>
-                  <a:srgbClr val="888888"/>
-                </a:solidFill>
-                <a:latin typeface="Calibri"/>
-              </a:defRPr>
-            </a:pPr>
-            <a:r>
-              <a:t>— Prof. Dr. Steffen Moritz, Uni of Hamburg</a:t>
+              <a:t>Stratified by PHQ-9 status</a:t>
+            </a:r>
+            <a:br/>
+            <a:br/>
+            <a:r>
+              <a:t>Discovery: 33 subjects (70%)</a:t>
+            </a:r>
+            <a:br/>
+            <a:r>
+              <a:t>Validation: 16 subjects (30%)</a:t>
+            </a:r>
+            <a:br/>
+            <a:br/>
+            <a:r>
+              <a:t>Class ratio preserved in both sets</a:t>
             </a:r>
           </a:p>
         </p:txBody>
@@ -9296,8 +10287,8 @@
         </p:nvSpPr>
         <p:spPr>
           <a:xfrm>
-            <a:off x="731520" y="2560320"/>
-            <a:ext cx="4846320" cy="1828800"/>
+            <a:off x="5943600" y="1097280"/>
+            <a:ext cx="4846320" cy="2560320"/>
           </a:xfrm>
           <a:prstGeom prst="roundRect">
             <a:avLst/>
@@ -9341,7 +10332,7 @@
         </p:nvSpPr>
         <p:spPr>
           <a:xfrm>
-            <a:off x="1005840" y="2651760"/>
+            <a:off x="6217920" y="1188720"/>
             <a:ext cx="4389120" cy="274320"/>
           </a:xfrm>
           <a:prstGeom prst="rect">
@@ -9364,7 +10355,7 @@
               </a:defRPr>
             </a:pPr>
             <a:r>
-              <a:t>The Problem with Biomarkers</a:t>
+              <a:t>Classifier Pipeline</a:t>
             </a:r>
           </a:p>
         </p:txBody>
@@ -9377,8 +10368,8 @@
         </p:nvSpPr>
         <p:spPr>
           <a:xfrm>
-            <a:off x="1005840" y="2926080"/>
-            <a:ext cx="4389120" cy="1097280"/>
+            <a:off x="6217920" y="1554480"/>
+            <a:ext cx="4389120" cy="1828800"/>
           </a:xfrm>
           <a:prstGeom prst="rect">
             <a:avLst/>
@@ -9400,15 +10391,27 @@
               </a:defRPr>
             </a:pPr>
             <a:r>
-              <a:t>• Predictive value of single biomarkers is never high</a:t>
+              <a:t>1. 187 temporal features (autocorr, CV, slope, std)</a:t>
             </a:r>
             <a:br/>
             <a:r>
-              <a:t>• Depression is gradual, not a sudden episode</a:t>
+              <a:t>   over 3/7/14/21-day windows</a:t>
             </a:r>
             <a:br/>
             <a:r>
-              <a:t>• HRV/sleep are stress markers, not depression-specific</a:t>
+              <a:t>2. HRV x sleep cross-domain interactions</a:t>
+            </a:r>
+            <a:br/>
+            <a:r>
+              <a:t>3. Per-subject z-scored composites</a:t>
+            </a:r>
+            <a:br/>
+            <a:r>
+              <a:t>4. LOSO-CV — feature selection INSIDE each fold</a:t>
+            </a:r>
+            <a:br/>
+            <a:r>
+              <a:t>5. Logistic Regression with top-10 features</a:t>
             </a:r>
           </a:p>
         </p:txBody>
@@ -9421,132 +10424,7 @@
         </p:nvSpPr>
         <p:spPr>
           <a:xfrm>
-            <a:off x="5943600" y="2560320"/>
-            <a:ext cx="4846320" cy="1828800"/>
-          </a:xfrm>
-          <a:prstGeom prst="roundRect">
-            <a:avLst/>
-          </a:prstGeom>
-          <a:solidFill>
-            <a:srgbClr val="0D201C"/>
-          </a:solidFill>
-          <a:ln w="12700">
-            <a:solidFill>
-              <a:srgbClr val="333344"/>
-            </a:solidFill>
-          </a:ln>
-        </p:spPr>
-        <p:style>
-          <a:lnRef idx="1">
-            <a:schemeClr val="accent1"/>
-          </a:lnRef>
-          <a:fillRef idx="3">
-            <a:schemeClr val="accent1"/>
-          </a:fillRef>
-          <a:effectRef idx="2">
-            <a:schemeClr val="accent1"/>
-          </a:effectRef>
-          <a:fontRef idx="minor">
-            <a:schemeClr val="lt1"/>
-          </a:fontRef>
-        </p:style>
-        <p:txBody>
-          <a:bodyPr rtlCol="0" anchor="ctr"/>
-          <a:lstStyle/>
-          <a:p>
-            <a:pPr algn="ctr"/>
-          </a:p>
-        </p:txBody>
-      </p:sp>
-      <p:sp>
-        <p:nvSpPr>
-          <p:cNvPr id="10" name="TextBox 9"/>
-          <p:cNvSpPr txBox="1"/>
-          <p:nvPr/>
-        </p:nvSpPr>
-        <p:spPr>
-          <a:xfrm>
-            <a:off x="6217920" y="2651760"/>
-            <a:ext cx="4389120" cy="274320"/>
-          </a:xfrm>
-          <a:prstGeom prst="rect">
-            <a:avLst/>
-          </a:prstGeom>
-          <a:noFill/>
-        </p:spPr>
-        <p:txBody>
-          <a:bodyPr wrap="square">
-            <a:spAutoFit/>
-          </a:bodyPr>
-          <a:lstStyle/>
-          <a:p>
-            <a:pPr algn="l">
-              <a:defRPr sz="1600" b="1">
-                <a:solidFill>
-                  <a:srgbClr val="00D4AA"/>
-                </a:solidFill>
-                <a:latin typeface="Calibri"/>
-              </a:defRPr>
-            </a:pPr>
-            <a:r>
-              <a:t>Our Answer: Monitor + Intervene</a:t>
-            </a:r>
-          </a:p>
-        </p:txBody>
-      </p:sp>
-      <p:sp>
-        <p:nvSpPr>
-          <p:cNvPr id="11" name="TextBox 10"/>
-          <p:cNvSpPr txBox="1"/>
-          <p:nvPr/>
-        </p:nvSpPr>
-        <p:spPr>
-          <a:xfrm>
-            <a:off x="6217920" y="2926080"/>
-            <a:ext cx="4389120" cy="1097280"/>
-          </a:xfrm>
-          <a:prstGeom prst="rect">
-            <a:avLst/>
-          </a:prstGeom>
-          <a:noFill/>
-        </p:spPr>
-        <p:txBody>
-          <a:bodyPr wrap="square">
-            <a:spAutoFit/>
-          </a:bodyPr>
-          <a:lstStyle/>
-          <a:p>
-            <a:pPr algn="l">
-              <a:defRPr sz="1300" b="0">
-                <a:solidFill>
-                  <a:srgbClr val="E0E0E0"/>
-                </a:solidFill>
-                <a:latin typeface="Calibri"/>
-              </a:defRPr>
-            </a:pPr>
-            <a:r>
-              <a:t>• Detect sleep destabilization early from wearables</a:t>
-            </a:r>
-            <a:br/>
-            <a:r>
-              <a:t>• Sleep is directly treatable (CBT-I, hygiene, meds)</a:t>
-            </a:r>
-            <a:br/>
-            <a:r>
-              <a:t>• Treating sleep improves depression, anxiety, stress</a:t>
-            </a:r>
-          </a:p>
-        </p:txBody>
-      </p:sp>
-      <p:sp>
-        <p:nvSpPr>
-          <p:cNvPr id="12" name="Rounded Rectangle 11"/>
-          <p:cNvSpPr/>
-          <p:nvPr/>
-        </p:nvSpPr>
-        <p:spPr>
-          <a:xfrm>
-            <a:off x="731520" y="4663440"/>
+            <a:off x="731520" y="3931920"/>
             <a:ext cx="10515600" cy="731520"/>
           </a:xfrm>
           <a:prstGeom prst="roundRect">
@@ -9585,13 +10463,13 @@
       </p:sp>
       <p:sp>
         <p:nvSpPr>
-          <p:cNvPr id="13" name="TextBox 12"/>
-          <p:cNvSpPr txBox="1"/>
-          <p:nvPr/>
-        </p:nvSpPr>
-        <p:spPr>
-          <a:xfrm>
-            <a:off x="1005840" y="4754880"/>
+          <p:cNvPr id="10" name="TextBox 9"/>
+          <p:cNvSpPr txBox="1"/>
+          <p:nvPr/>
+        </p:nvSpPr>
+        <p:spPr>
+          <a:xfrm>
+            <a:off x="1005840" y="4023360"/>
             <a:ext cx="10058400" cy="548640"/>
           </a:xfrm>
           <a:prstGeom prst="rect">
@@ -9608,17 +10486,13 @@
             <a:pPr algn="ctr">
               <a:defRPr sz="1400" b="0">
                 <a:solidFill>
-                  <a:srgbClr val="E0E0E0"/>
-                </a:solidFill>
-                <a:latin typeface="Calibri"/>
-              </a:defRPr>
-            </a:pPr>
-            <a:r>
-              <a:t>We don't diagnose depression. We flag physiological destabilization — especially sleep —</a:t>
-            </a:r>
-            <a:br/>
-            <a:r>
-              <a:t>so clinicians can intervene before patients drop out.</a:t>
+                  <a:srgbClr val="00D4AA"/>
+                </a:solidFill>
+                <a:latin typeface="Calibri"/>
+              </a:defRPr>
+            </a:pPr>
+            <a:r>
+              <a:t>Key: Feature selection inside CV folds prevents data leakage. Subject-level stats prevent pseudoreplication.</a:t>
             </a:r>
           </a:p>
         </p:txBody>

</xml_diff>